<commit_message>
Material AppWeb - Angular
</commit_message>
<xml_diff>
--- a/AplicacionesWeb/Material de clases/Presentaciones/Deck_Angular22_REST.pptx
+++ b/AplicacionesWeb/Material de clases/Presentaciones/Deck_Angular22_REST.pptx
@@ -6461,7 +6461,7 @@
         </p:nvSpPr>
         <p:spPr>
           <a:xfrm>
-            <a:off x="548640" y="1417320"/>
+            <a:off x="521208" y="1353313"/>
             <a:ext cx="11091672" cy="457200"/>
           </a:xfrm>
           <a:prstGeom prst="rect">
@@ -6478,7 +6478,7 @@
               <a:buNone/>
             </a:pPr>
             <a:r>
-              <a:rPr lang="en-US" sz="1400" dirty="0">
+              <a:rPr lang="en-US" dirty="0">
                 <a:solidFill>
                   <a:srgbClr val="383A42"/>
                 </a:solidFill>
@@ -6488,7 +6488,7 @@
               </a:rPr>
               <a:t>La CLI genera una estructura estandar que sigue las convenciones del equipo de Angular. Cada carpeta y cada archivo tiene un rol claro.</a:t>
             </a:r>
-            <a:endParaRPr lang="en-US" sz="1400" dirty="0"/>
+            <a:endParaRPr lang="en-US" dirty="0"/>
           </a:p>
         </p:txBody>
       </p:sp>
@@ -6554,7 +6554,7 @@
           <a:bodyPr/>
           <a:lstStyle/>
           <a:p>
-            <a:endParaRPr lang="es-US"/>
+            <a:endParaRPr lang="es-US" sz="2400"/>
           </a:p>
         </p:txBody>
       </p:sp>
@@ -6583,7 +6583,7 @@
               <a:buNone/>
             </a:pPr>
             <a:r>
-              <a:rPr lang="en-US" sz="1000" b="1" dirty="0">
+              <a:rPr lang="en-US" sz="1100" b="1" dirty="0">
                 <a:solidFill>
                   <a:srgbClr val="FFFFFF"/>
                 </a:solidFill>
@@ -6593,7 +6593,7 @@
               </a:rPr>
               <a:t>tree</a:t>
             </a:r>
-            <a:endParaRPr lang="en-US" sz="1000" dirty="0"/>
+            <a:endParaRPr lang="en-US" sz="1100" dirty="0"/>
           </a:p>
         </p:txBody>
       </p:sp>
@@ -6605,7 +6605,7 @@
         </p:nvSpPr>
         <p:spPr>
           <a:xfrm>
-            <a:off x="640080" y="2886890"/>
+            <a:off x="570882" y="2423160"/>
             <a:ext cx="5852160" cy="3376749"/>
           </a:xfrm>
           <a:prstGeom prst="rect">
@@ -6622,7 +6622,7 @@
               <a:buNone/>
             </a:pPr>
             <a:r>
-              <a:rPr lang="en-US" sz="1100" dirty="0">
+              <a:rPr lang="en-US" sz="1400" dirty="0">
                 <a:solidFill>
                   <a:srgbClr val="383A42"/>
                 </a:solidFill>
@@ -6633,7 +6633,7 @@
               <a:t>frontend/</a:t>
             </a:r>
             <a:r>
-              <a:rPr lang="en-US" sz="1100" dirty="0">
+              <a:rPr lang="en-US" sz="1400" dirty="0">
                 <a:solidFill>
                   <a:srgbClr val="000000"/>
                 </a:solidFill>
@@ -6641,14 +6641,14 @@
               <a:t>
 </a:t>
             </a:r>
-            <a:endParaRPr lang="en-US" sz="1100" dirty="0"/>
-          </a:p>
-          <a:p>
-            <a:pPr marL="0" indent="0">
-              <a:buNone/>
-            </a:pPr>
-            <a:r>
-              <a:rPr lang="en-US" sz="1100" dirty="0">
+            <a:endParaRPr lang="en-US" sz="1400" dirty="0"/>
+          </a:p>
+          <a:p>
+            <a:pPr marL="0" indent="0">
+              <a:buNone/>
+            </a:pPr>
+            <a:r>
+              <a:rPr lang="en-US" sz="1400" dirty="0">
                 <a:solidFill>
                   <a:srgbClr val="383A42"/>
                 </a:solidFill>
@@ -6659,7 +6659,7 @@
               <a:t>|-- </a:t>
             </a:r>
             <a:r>
-              <a:rPr lang="en-US" sz="1100" dirty="0" err="1">
+              <a:rPr lang="en-US" sz="1400" dirty="0" err="1">
                 <a:solidFill>
                   <a:srgbClr val="383A42"/>
                 </a:solidFill>
@@ -6670,7 +6670,7 @@
               <a:t>src</a:t>
             </a:r>
             <a:r>
-              <a:rPr lang="en-US" sz="1100" dirty="0">
+              <a:rPr lang="en-US" sz="1400" dirty="0">
                 <a:solidFill>
                   <a:srgbClr val="383A42"/>
                 </a:solidFill>
@@ -6680,14 +6680,14 @@
               </a:rPr>
               <a:t>/</a:t>
             </a:r>
-            <a:endParaRPr lang="en-US" sz="1100" dirty="0"/>
-          </a:p>
-          <a:p>
-            <a:pPr marL="0" indent="0">
-              <a:buNone/>
-            </a:pPr>
-            <a:r>
-              <a:rPr lang="en-US" sz="1100" dirty="0">
+            <a:endParaRPr lang="en-US" sz="1400" dirty="0"/>
+          </a:p>
+          <a:p>
+            <a:pPr marL="0" indent="0">
+              <a:buNone/>
+            </a:pPr>
+            <a:r>
+              <a:rPr lang="en-US" sz="1400" dirty="0">
                 <a:solidFill>
                   <a:srgbClr val="383A42"/>
                 </a:solidFill>
@@ -6697,14 +6697,14 @@
               </a:rPr>
               <a:t>|   |-- app/</a:t>
             </a:r>
-            <a:endParaRPr lang="en-US" sz="1100" dirty="0"/>
-          </a:p>
-          <a:p>
-            <a:pPr marL="0" indent="0">
-              <a:buNone/>
-            </a:pPr>
-            <a:r>
-              <a:rPr lang="en-US" sz="1100" dirty="0">
+            <a:endParaRPr lang="en-US" sz="1400" dirty="0"/>
+          </a:p>
+          <a:p>
+            <a:pPr marL="0" indent="0">
+              <a:buNone/>
+            </a:pPr>
+            <a:r>
+              <a:rPr lang="en-US" sz="1400" dirty="0">
                 <a:solidFill>
                   <a:srgbClr val="383A42"/>
                 </a:solidFill>
@@ -6715,7 +6715,7 @@
               <a:t>|   |   |-- </a:t>
             </a:r>
             <a:r>
-              <a:rPr lang="en-US" sz="1100" dirty="0" err="1">
+              <a:rPr lang="en-US" sz="1400" dirty="0" err="1">
                 <a:solidFill>
                   <a:srgbClr val="383A42"/>
                 </a:solidFill>
@@ -6725,14 +6725,14 @@
               </a:rPr>
               <a:t>app.component.ts</a:t>
             </a:r>
-            <a:endParaRPr lang="en-US" sz="1100" dirty="0"/>
-          </a:p>
-          <a:p>
-            <a:pPr marL="0" indent="0">
-              <a:buNone/>
-            </a:pPr>
-            <a:r>
-              <a:rPr lang="en-US" sz="1100" dirty="0">
+            <a:endParaRPr lang="en-US" sz="1400" dirty="0"/>
+          </a:p>
+          <a:p>
+            <a:pPr marL="0" indent="0">
+              <a:buNone/>
+            </a:pPr>
+            <a:r>
+              <a:rPr lang="en-US" sz="1400" dirty="0">
                 <a:solidFill>
                   <a:srgbClr val="383A42"/>
                 </a:solidFill>
@@ -6742,14 +6742,14 @@
               </a:rPr>
               <a:t>|   |   |-- app.component.html</a:t>
             </a:r>
-            <a:endParaRPr lang="en-US" sz="1100" dirty="0"/>
-          </a:p>
-          <a:p>
-            <a:pPr marL="0" indent="0">
-              <a:buNone/>
-            </a:pPr>
-            <a:r>
-              <a:rPr lang="en-US" sz="1100" dirty="0">
+            <a:endParaRPr lang="en-US" sz="1400" dirty="0"/>
+          </a:p>
+          <a:p>
+            <a:pPr marL="0" indent="0">
+              <a:buNone/>
+            </a:pPr>
+            <a:r>
+              <a:rPr lang="en-US" sz="1400" dirty="0">
                 <a:solidFill>
                   <a:srgbClr val="383A42"/>
                 </a:solidFill>
@@ -6759,14 +6759,14 @@
               </a:rPr>
               <a:t>|   |   |-- app.component.css</a:t>
             </a:r>
-            <a:endParaRPr lang="en-US" sz="1100" dirty="0"/>
-          </a:p>
-          <a:p>
-            <a:pPr marL="0" indent="0">
-              <a:buNone/>
-            </a:pPr>
-            <a:r>
-              <a:rPr lang="en-US" sz="1100" dirty="0">
+            <a:endParaRPr lang="en-US" sz="1400" dirty="0"/>
+          </a:p>
+          <a:p>
+            <a:pPr marL="0" indent="0">
+              <a:buNone/>
+            </a:pPr>
+            <a:r>
+              <a:rPr lang="en-US" sz="1400" dirty="0">
                 <a:solidFill>
                   <a:srgbClr val="383A42"/>
                 </a:solidFill>
@@ -6777,7 +6777,7 @@
               <a:t>|   |   |-- </a:t>
             </a:r>
             <a:r>
-              <a:rPr lang="en-US" sz="1100" dirty="0" err="1">
+              <a:rPr lang="en-US" sz="1400" dirty="0" err="1">
                 <a:solidFill>
                   <a:srgbClr val="383A42"/>
                 </a:solidFill>
@@ -6787,14 +6787,14 @@
               </a:rPr>
               <a:t>app.config.ts</a:t>
             </a:r>
-            <a:endParaRPr lang="en-US" sz="1100" dirty="0"/>
-          </a:p>
-          <a:p>
-            <a:pPr marL="0" indent="0">
-              <a:buNone/>
-            </a:pPr>
-            <a:r>
-              <a:rPr lang="en-US" sz="1100" dirty="0">
+            <a:endParaRPr lang="en-US" sz="1400" dirty="0"/>
+          </a:p>
+          <a:p>
+            <a:pPr marL="0" indent="0">
+              <a:buNone/>
+            </a:pPr>
+            <a:r>
+              <a:rPr lang="en-US" sz="1400" dirty="0">
                 <a:solidFill>
                   <a:srgbClr val="383A42"/>
                 </a:solidFill>
@@ -6805,7 +6805,7 @@
               <a:t>|   |   </a:t>
             </a:r>
             <a:r>
-              <a:rPr lang="en-US" sz="1100" dirty="0">
+              <a:rPr lang="en-US" sz="1400" dirty="0">
                 <a:solidFill>
                   <a:srgbClr val="C41A16"/>
                 </a:solidFill>
@@ -6816,7 +6816,7 @@
               <a:t>`-- </a:t>
             </a:r>
             <a:r>
-              <a:rPr lang="en-US" sz="1100" dirty="0" err="1">
+              <a:rPr lang="en-US" sz="1400" dirty="0" err="1">
                 <a:solidFill>
                   <a:srgbClr val="C41A16"/>
                 </a:solidFill>
@@ -6826,14 +6826,14 @@
               </a:rPr>
               <a:t>app.routes.ts</a:t>
             </a:r>
-            <a:endParaRPr lang="en-US" sz="1100" dirty="0"/>
-          </a:p>
-          <a:p>
-            <a:pPr marL="0" indent="0">
-              <a:buNone/>
-            </a:pPr>
-            <a:r>
-              <a:rPr lang="en-US" sz="1100" dirty="0">
+            <a:endParaRPr lang="en-US" sz="1400" dirty="0"/>
+          </a:p>
+          <a:p>
+            <a:pPr marL="0" indent="0">
+              <a:buNone/>
+            </a:pPr>
+            <a:r>
+              <a:rPr lang="en-US" sz="1400" dirty="0">
                 <a:solidFill>
                   <a:srgbClr val="383A42"/>
                 </a:solidFill>
@@ -6843,14 +6843,14 @@
               </a:rPr>
               <a:t>|   |-- assets/</a:t>
             </a:r>
-            <a:endParaRPr lang="en-US" sz="1100" dirty="0"/>
-          </a:p>
-          <a:p>
-            <a:pPr marL="0" indent="0">
-              <a:buNone/>
-            </a:pPr>
-            <a:r>
-              <a:rPr lang="en-US" sz="1100" dirty="0">
+            <a:endParaRPr lang="en-US" sz="1400" dirty="0"/>
+          </a:p>
+          <a:p>
+            <a:pPr marL="0" indent="0">
+              <a:buNone/>
+            </a:pPr>
+            <a:r>
+              <a:rPr lang="en-US" sz="1400" dirty="0">
                 <a:solidFill>
                   <a:srgbClr val="383A42"/>
                 </a:solidFill>
@@ -6860,14 +6860,14 @@
               </a:rPr>
               <a:t>|   |-- index.html</a:t>
             </a:r>
-            <a:endParaRPr lang="en-US" sz="1100" dirty="0"/>
-          </a:p>
-          <a:p>
-            <a:pPr marL="0" indent="0">
-              <a:buNone/>
-            </a:pPr>
-            <a:r>
-              <a:rPr lang="en-US" sz="1100" dirty="0">
+            <a:endParaRPr lang="en-US" sz="1400" dirty="0"/>
+          </a:p>
+          <a:p>
+            <a:pPr marL="0" indent="0">
+              <a:buNone/>
+            </a:pPr>
+            <a:r>
+              <a:rPr lang="en-US" sz="1400" dirty="0">
                 <a:solidFill>
                   <a:srgbClr val="383A42"/>
                 </a:solidFill>
@@ -6878,7 +6878,7 @@
               <a:t>|   |-- </a:t>
             </a:r>
             <a:r>
-              <a:rPr lang="en-US" sz="1100" dirty="0" err="1">
+              <a:rPr lang="en-US" sz="1400" dirty="0" err="1">
                 <a:solidFill>
                   <a:srgbClr val="383A42"/>
                 </a:solidFill>
@@ -6888,14 +6888,14 @@
               </a:rPr>
               <a:t>main.ts</a:t>
             </a:r>
-            <a:endParaRPr lang="en-US" sz="1100" dirty="0"/>
-          </a:p>
-          <a:p>
-            <a:pPr marL="0" indent="0">
-              <a:buNone/>
-            </a:pPr>
-            <a:r>
-              <a:rPr lang="en-US" sz="1100" dirty="0">
+            <a:endParaRPr lang="en-US" sz="1400" dirty="0"/>
+          </a:p>
+          <a:p>
+            <a:pPr marL="0" indent="0">
+              <a:buNone/>
+            </a:pPr>
+            <a:r>
+              <a:rPr lang="en-US" sz="1400" dirty="0">
                 <a:solidFill>
                   <a:srgbClr val="383A42"/>
                 </a:solidFill>
@@ -6906,7 +6906,7 @@
               <a:t>|   </a:t>
             </a:r>
             <a:r>
-              <a:rPr lang="en-US" sz="1100" dirty="0">
+              <a:rPr lang="en-US" sz="1400" dirty="0">
                 <a:solidFill>
                   <a:srgbClr val="C41A16"/>
                 </a:solidFill>
@@ -6916,14 +6916,14 @@
               </a:rPr>
               <a:t>`-- styles.css</a:t>
             </a:r>
-            <a:endParaRPr lang="en-US" sz="1100" dirty="0"/>
-          </a:p>
-          <a:p>
-            <a:pPr marL="0" indent="0">
-              <a:buNone/>
-            </a:pPr>
-            <a:r>
-              <a:rPr lang="en-US" sz="1100" dirty="0">
+            <a:endParaRPr lang="en-US" sz="1400" dirty="0"/>
+          </a:p>
+          <a:p>
+            <a:pPr marL="0" indent="0">
+              <a:buNone/>
+            </a:pPr>
+            <a:r>
+              <a:rPr lang="en-US" sz="1400" dirty="0">
                 <a:solidFill>
                   <a:srgbClr val="383A42"/>
                 </a:solidFill>
@@ -6934,7 +6934,7 @@
               <a:t>|-- </a:t>
             </a:r>
             <a:r>
-              <a:rPr lang="en-US" sz="1100" dirty="0" err="1">
+              <a:rPr lang="en-US" sz="1400" dirty="0" err="1">
                 <a:solidFill>
                   <a:srgbClr val="383A42"/>
                 </a:solidFill>
@@ -6944,14 +6944,14 @@
               </a:rPr>
               <a:t>angular.json</a:t>
             </a:r>
-            <a:endParaRPr lang="en-US" sz="1100" dirty="0"/>
-          </a:p>
-          <a:p>
-            <a:pPr marL="0" indent="0">
-              <a:buNone/>
-            </a:pPr>
-            <a:r>
-              <a:rPr lang="en-US" sz="1100" dirty="0">
+            <a:endParaRPr lang="en-US" sz="1400" dirty="0"/>
+          </a:p>
+          <a:p>
+            <a:pPr marL="0" indent="0">
+              <a:buNone/>
+            </a:pPr>
+            <a:r>
+              <a:rPr lang="en-US" sz="1400" dirty="0">
                 <a:solidFill>
                   <a:srgbClr val="383A42"/>
                 </a:solidFill>
@@ -6962,7 +6962,7 @@
               <a:t>|-- </a:t>
             </a:r>
             <a:r>
-              <a:rPr lang="en-US" sz="1100" dirty="0" err="1">
+              <a:rPr lang="en-US" sz="1400" dirty="0" err="1">
                 <a:solidFill>
                   <a:srgbClr val="383A42"/>
                 </a:solidFill>
@@ -6972,14 +6972,14 @@
               </a:rPr>
               <a:t>package.json</a:t>
             </a:r>
-            <a:endParaRPr lang="en-US" sz="1100" dirty="0"/>
-          </a:p>
-          <a:p>
-            <a:pPr marL="0" indent="0">
-              <a:buNone/>
-            </a:pPr>
-            <a:r>
-              <a:rPr lang="en-US" sz="1100" dirty="0">
+            <a:endParaRPr lang="en-US" sz="1400" dirty="0"/>
+          </a:p>
+          <a:p>
+            <a:pPr marL="0" indent="0">
+              <a:buNone/>
+            </a:pPr>
+            <a:r>
+              <a:rPr lang="en-US" sz="1400" dirty="0">
                 <a:solidFill>
                   <a:srgbClr val="383A42"/>
                 </a:solidFill>
@@ -6990,7 +6990,7 @@
               <a:t>|-- </a:t>
             </a:r>
             <a:r>
-              <a:rPr lang="en-US" sz="1100" dirty="0" err="1">
+              <a:rPr lang="en-US" sz="1400" dirty="0" err="1">
                 <a:solidFill>
                   <a:srgbClr val="383A42"/>
                 </a:solidFill>
@@ -7000,14 +7000,14 @@
               </a:rPr>
               <a:t>tsconfig.json</a:t>
             </a:r>
-            <a:endParaRPr lang="en-US" sz="1100" dirty="0"/>
-          </a:p>
-          <a:p>
-            <a:pPr marL="0" indent="0">
-              <a:buNone/>
-            </a:pPr>
-            <a:r>
-              <a:rPr lang="en-US" sz="1100" dirty="0">
+            <a:endParaRPr lang="en-US" sz="1400" dirty="0"/>
+          </a:p>
+          <a:p>
+            <a:pPr marL="0" indent="0">
+              <a:buNone/>
+            </a:pPr>
+            <a:r>
+              <a:rPr lang="en-US" sz="1400" dirty="0">
                 <a:solidFill>
                   <a:srgbClr val="C41A16"/>
                 </a:solidFill>
@@ -7018,7 +7018,7 @@
               <a:t>`-- node_modules/    (dependencias)</a:t>
             </a:r>
             <a:r>
-              <a:rPr lang="en-US" sz="1100" dirty="0">
+              <a:rPr lang="en-US" sz="1400" dirty="0">
                 <a:solidFill>
                   <a:srgbClr val="000000"/>
                 </a:solidFill>
@@ -7026,7 +7026,7 @@
               <a:t>
 </a:t>
             </a:r>
-            <a:endParaRPr lang="en-US" sz="1100" dirty="0"/>
+            <a:endParaRPr lang="en-US" sz="1400" dirty="0"/>
           </a:p>
         </p:txBody>
       </p:sp>
@@ -7055,7 +7055,7 @@
               <a:buNone/>
             </a:pPr>
             <a:r>
-              <a:rPr lang="en-US" sz="1300" b="1" dirty="0">
+              <a:rPr lang="en-US" sz="1600" b="1" dirty="0">
                 <a:solidFill>
                   <a:srgbClr val="0B3D24"/>
                 </a:solidFill>
@@ -7066,7 +7066,7 @@
               <a:t>src/app/</a:t>
             </a:r>
             <a:r>
-              <a:rPr lang="en-US" sz="1200" dirty="0">
+              <a:rPr lang="en-US" sz="1600" dirty="0">
                 <a:solidFill>
                   <a:srgbClr val="383A42"/>
                 </a:solidFill>
@@ -7077,14 +7077,14 @@
               <a:t>  --- Codigo TypeScript de la aplicacion.
 </a:t>
             </a:r>
-            <a:endParaRPr lang="en-US" sz="1300" dirty="0"/>
-          </a:p>
-          <a:p>
-            <a:pPr marL="0" indent="0">
-              <a:buNone/>
-            </a:pPr>
-            <a:r>
-              <a:rPr lang="en-US" sz="1300" b="1" dirty="0">
+            <a:endParaRPr lang="en-US" sz="1600" dirty="0"/>
+          </a:p>
+          <a:p>
+            <a:pPr marL="0" indent="0">
+              <a:buNone/>
+            </a:pPr>
+            <a:r>
+              <a:rPr lang="en-US" sz="1600" b="1" dirty="0">
                 <a:solidFill>
                   <a:srgbClr val="0B3D24"/>
                 </a:solidFill>
@@ -7095,7 +7095,7 @@
               <a:t>app.config.ts</a:t>
             </a:r>
             <a:r>
-              <a:rPr lang="en-US" sz="1200" dirty="0">
+              <a:rPr lang="en-US" sz="1600" dirty="0">
                 <a:solidFill>
                   <a:srgbClr val="383A42"/>
                 </a:solidFill>
@@ -7106,14 +7106,14 @@
               <a:t>  --- Configura providers globales (HttpClient, Router).
 </a:t>
             </a:r>
-            <a:endParaRPr lang="en-US" sz="1300" dirty="0"/>
-          </a:p>
-          <a:p>
-            <a:pPr marL="0" indent="0">
-              <a:buNone/>
-            </a:pPr>
-            <a:r>
-              <a:rPr lang="en-US" sz="1300" b="1" dirty="0">
+            <a:endParaRPr lang="en-US" sz="1600" dirty="0"/>
+          </a:p>
+          <a:p>
+            <a:pPr marL="0" indent="0">
+              <a:buNone/>
+            </a:pPr>
+            <a:r>
+              <a:rPr lang="en-US" sz="1600" b="1" dirty="0">
                 <a:solidFill>
                   <a:srgbClr val="0B3D24"/>
                 </a:solidFill>
@@ -7124,7 +7124,7 @@
               <a:t>app.routes.ts</a:t>
             </a:r>
             <a:r>
-              <a:rPr lang="en-US" sz="1200" dirty="0">
+              <a:rPr lang="en-US" sz="1600" dirty="0">
                 <a:solidFill>
                   <a:srgbClr val="383A42"/>
                 </a:solidFill>
@@ -7135,14 +7135,14 @@
               <a:t>  --- Rutas del enrutador: URL a Componente.
 </a:t>
             </a:r>
-            <a:endParaRPr lang="en-US" sz="1300" dirty="0"/>
-          </a:p>
-          <a:p>
-            <a:pPr marL="0" indent="0">
-              <a:buNone/>
-            </a:pPr>
-            <a:r>
-              <a:rPr lang="en-US" sz="1300" b="1" dirty="0">
+            <a:endParaRPr lang="en-US" sz="1600" dirty="0"/>
+          </a:p>
+          <a:p>
+            <a:pPr marL="0" indent="0">
+              <a:buNone/>
+            </a:pPr>
+            <a:r>
+              <a:rPr lang="en-US" sz="1600" b="1" dirty="0">
                 <a:solidFill>
                   <a:srgbClr val="0B3D24"/>
                 </a:solidFill>
@@ -7153,7 +7153,7 @@
               <a:t>styles.css</a:t>
             </a:r>
             <a:r>
-              <a:rPr lang="en-US" sz="1200" dirty="0">
+              <a:rPr lang="en-US" sz="1600" dirty="0">
                 <a:solidFill>
                   <a:srgbClr val="383A42"/>
                 </a:solidFill>
@@ -7164,14 +7164,14 @@
               <a:t>  --- Estilos globales del proyecto. Aqui se importa el estilos.css compartido de BiblioUTEQ.
 </a:t>
             </a:r>
-            <a:endParaRPr lang="en-US" sz="1300" dirty="0"/>
-          </a:p>
-          <a:p>
-            <a:pPr marL="0" indent="0">
-              <a:buNone/>
-            </a:pPr>
-            <a:r>
-              <a:rPr lang="en-US" sz="1300" b="1" dirty="0">
+            <a:endParaRPr lang="en-US" sz="1600" dirty="0"/>
+          </a:p>
+          <a:p>
+            <a:pPr marL="0" indent="0">
+              <a:buNone/>
+            </a:pPr>
+            <a:r>
+              <a:rPr lang="en-US" sz="1600" b="1" dirty="0">
                 <a:solidFill>
                   <a:srgbClr val="0B3D24"/>
                 </a:solidFill>
@@ -7182,7 +7182,7 @@
               <a:t>angular.json</a:t>
             </a:r>
             <a:r>
-              <a:rPr lang="en-US" sz="1200" dirty="0">
+              <a:rPr lang="en-US" sz="1600" dirty="0">
                 <a:solidFill>
                   <a:srgbClr val="383A42"/>
                 </a:solidFill>
@@ -7193,14 +7193,14 @@
               <a:t>  --- Configuracion del build (assets, budgets).
 </a:t>
             </a:r>
-            <a:endParaRPr lang="en-US" sz="1300" dirty="0"/>
-          </a:p>
-          <a:p>
-            <a:pPr marL="0" indent="0">
-              <a:buNone/>
-            </a:pPr>
-            <a:r>
-              <a:rPr lang="en-US" sz="1300" b="1" dirty="0">
+            <a:endParaRPr lang="en-US" sz="1600" dirty="0"/>
+          </a:p>
+          <a:p>
+            <a:pPr marL="0" indent="0">
+              <a:buNone/>
+            </a:pPr>
+            <a:r>
+              <a:rPr lang="en-US" sz="1600" b="1" dirty="0">
                 <a:solidFill>
                   <a:srgbClr val="0B3D24"/>
                 </a:solidFill>
@@ -7211,7 +7211,7 @@
               <a:t>package.json</a:t>
             </a:r>
             <a:r>
-              <a:rPr lang="en-US" sz="1200" dirty="0">
+              <a:rPr lang="en-US" sz="1600" dirty="0">
                 <a:solidFill>
                   <a:srgbClr val="383A42"/>
                 </a:solidFill>
@@ -7221,7 +7221,7 @@
               </a:rPr>
               <a:t>  --- Dependencias y scripts npm.</a:t>
             </a:r>
-            <a:endParaRPr lang="en-US" sz="1300" dirty="0"/>
+            <a:endParaRPr lang="en-US" sz="1600" dirty="0"/>
           </a:p>
         </p:txBody>
       </p:sp>
@@ -7525,7 +7525,7 @@
               <a:buNone/>
             </a:pPr>
             <a:r>
-              <a:rPr lang="en-US" sz="1500" dirty="0">
+              <a:rPr lang="en-US" dirty="0">
                 <a:solidFill>
                   <a:srgbClr val="383A42"/>
                 </a:solidFill>
@@ -7535,7 +7535,7 @@
               </a:rPr>
               <a:t>El comando ng serve compila el proyecto, inicia un servidor de desarrollo en localhost:4200 y activa la recarga en caliente: cualquier cambio en el codigo actualiza el navegador sin perder el estado.</a:t>
             </a:r>
-            <a:endParaRPr lang="en-US" sz="1500" dirty="0"/>
+            <a:endParaRPr lang="en-US" dirty="0"/>
           </a:p>
         </p:txBody>
       </p:sp>
@@ -7569,7 +7569,7 @@
           <a:bodyPr/>
           <a:lstStyle/>
           <a:p>
-            <a:endParaRPr lang="es-US"/>
+            <a:endParaRPr lang="es-US" sz="2400"/>
           </a:p>
         </p:txBody>
       </p:sp>
@@ -7601,7 +7601,7 @@
           <a:bodyPr/>
           <a:lstStyle/>
           <a:p>
-            <a:endParaRPr lang="es-US"/>
+            <a:endParaRPr lang="es-US" sz="2400"/>
           </a:p>
         </p:txBody>
       </p:sp>
@@ -7630,7 +7630,7 @@
               <a:buNone/>
             </a:pPr>
             <a:r>
-              <a:rPr lang="en-US" sz="1000" b="1" dirty="0">
+              <a:rPr lang="en-US" sz="1100" b="1" dirty="0">
                 <a:solidFill>
                   <a:srgbClr val="FFFFFF"/>
                 </a:solidFill>
@@ -7640,7 +7640,7 @@
               </a:rPr>
               <a:t>terminal</a:t>
             </a:r>
-            <a:endParaRPr lang="en-US" sz="1000" dirty="0"/>
+            <a:endParaRPr lang="en-US" sz="1100" dirty="0"/>
           </a:p>
         </p:txBody>
       </p:sp>
@@ -7669,7 +7669,7 @@
               <a:buNone/>
             </a:pPr>
             <a:r>
-              <a:rPr lang="en-US" sz="1200" i="1" dirty="0">
+              <a:rPr lang="en-US" sz="1600" i="1" dirty="0">
                 <a:solidFill>
                   <a:srgbClr val="717171"/>
                 </a:solidFill>
@@ -7681,7 +7681,7 @@
 </a:t>
             </a:r>
             <a:r>
-              <a:rPr lang="en-US" sz="1200" b="1" dirty="0">
+              <a:rPr lang="en-US" sz="1600" b="1" dirty="0">
                 <a:solidFill>
                   <a:srgbClr val="0057AE"/>
                 </a:solidFill>
@@ -7692,7 +7692,7 @@
               <a:t>ng</a:t>
             </a:r>
             <a:r>
-              <a:rPr lang="en-US" sz="1200" dirty="0">
+              <a:rPr lang="en-US" sz="1600" dirty="0">
                 <a:solidFill>
                   <a:srgbClr val="383A42"/>
                 </a:solidFill>
@@ -7703,7 +7703,7 @@
               <a:t> </a:t>
             </a:r>
             <a:r>
-              <a:rPr lang="en-US" sz="1200" b="1" dirty="0">
+              <a:rPr lang="en-US" sz="1600" b="1" dirty="0">
                 <a:solidFill>
                   <a:srgbClr val="0057AE"/>
                 </a:solidFill>
@@ -7714,7 +7714,7 @@
               <a:t>serve</a:t>
             </a:r>
             <a:r>
-              <a:rPr lang="en-US" sz="1200" dirty="0">
+              <a:rPr lang="en-US" sz="1600" dirty="0">
                 <a:solidFill>
                   <a:srgbClr val="383A42"/>
                 </a:solidFill>
@@ -7724,23 +7724,14 @@
               </a:rPr>
               <a:t> --open</a:t>
             </a:r>
-            <a:r>
-              <a:rPr lang="en-US" sz="1200" dirty="0">
-                <a:solidFill>
-                  <a:srgbClr val="000000"/>
-                </a:solidFill>
-              </a:rPr>
-              <a:t>
-</a:t>
-            </a:r>
-            <a:endParaRPr lang="en-US" sz="1200" dirty="0"/>
-          </a:p>
-          <a:p>
-            <a:pPr marL="0" indent="0">
-              <a:buNone/>
-            </a:pPr>
-            <a:r>
-              <a:rPr lang="en-US" sz="1200" i="1" dirty="0">
+            <a:endParaRPr lang="en-US" sz="1600" dirty="0"/>
+          </a:p>
+          <a:p>
+            <a:pPr marL="0" indent="0">
+              <a:buNone/>
+            </a:pPr>
+            <a:r>
+              <a:rPr lang="en-US" sz="1600" i="1" dirty="0">
                 <a:solidFill>
                   <a:srgbClr val="717171"/>
                 </a:solidFill>
@@ -7754,7 +7745,7 @@
 # Local:   http://localhost:4200/
 </a:t>
             </a:r>
-            <a:endParaRPr lang="en-US" sz="1200" dirty="0"/>
+            <a:endParaRPr lang="en-US" sz="1600" dirty="0"/>
           </a:p>
         </p:txBody>
       </p:sp>
@@ -7788,7 +7779,7 @@
           <a:bodyPr/>
           <a:lstStyle/>
           <a:p>
-            <a:endParaRPr lang="es-US"/>
+            <a:endParaRPr lang="es-US" sz="2400"/>
           </a:p>
         </p:txBody>
       </p:sp>
@@ -7820,7 +7811,7 @@
           <a:bodyPr/>
           <a:lstStyle/>
           <a:p>
-            <a:endParaRPr lang="es-US"/>
+            <a:endParaRPr lang="es-US" sz="2400"/>
           </a:p>
         </p:txBody>
       </p:sp>
@@ -7849,7 +7840,7 @@
               <a:buNone/>
             </a:pPr>
             <a:r>
-              <a:rPr lang="en-US" sz="1300" b="1" dirty="0">
+              <a:rPr lang="en-US" sz="1600" b="1" dirty="0">
                 <a:solidFill>
                   <a:srgbClr val="FFFFFF"/>
                 </a:solidFill>
@@ -7859,7 +7850,7 @@
               </a:rPr>
               <a:t>Que hace la CLI internamente</a:t>
             </a:r>
-            <a:endParaRPr lang="en-US" sz="1300" dirty="0"/>
+            <a:endParaRPr lang="en-US" sz="1600" dirty="0"/>
           </a:p>
         </p:txBody>
       </p:sp>
@@ -7891,7 +7882,7 @@
               <a:buNone/>
             </a:pPr>
             <a:r>
-              <a:rPr lang="en-US" sz="1200" dirty="0">
+              <a:rPr lang="en-US" sz="1600" dirty="0">
                 <a:solidFill>
                   <a:srgbClr val="383A42"/>
                 </a:solidFill>
@@ -7901,7 +7892,7 @@
               </a:rPr>
               <a:t>Compila TypeScript a JavaScript (esbuild), agrupa modulos, procesa CSS, sirve por HTTP con recarga en caliente y expone sourcemaps para depurar en el navegador.</a:t>
             </a:r>
-            <a:endParaRPr lang="en-US" sz="1200" dirty="0"/>
+            <a:endParaRPr lang="en-US" sz="1600" dirty="0"/>
           </a:p>
         </p:txBody>
       </p:sp>
@@ -7935,7 +7926,7 @@
           <a:bodyPr/>
           <a:lstStyle/>
           <a:p>
-            <a:endParaRPr lang="es-US"/>
+            <a:endParaRPr lang="es-US" sz="2400"/>
           </a:p>
         </p:txBody>
       </p:sp>
@@ -7967,7 +7958,7 @@
           <a:bodyPr/>
           <a:lstStyle/>
           <a:p>
-            <a:endParaRPr lang="es-US"/>
+            <a:endParaRPr lang="es-US" sz="2400"/>
           </a:p>
         </p:txBody>
       </p:sp>
@@ -7996,7 +7987,7 @@
               <a:buNone/>
             </a:pPr>
             <a:r>
-              <a:rPr lang="en-US" sz="1300" b="1" dirty="0">
+              <a:rPr lang="en-US" sz="1600" b="1" dirty="0">
                 <a:solidFill>
                   <a:srgbClr val="FFFFFF"/>
                 </a:solidFill>
@@ -8006,7 +7997,7 @@
               </a:rPr>
               <a:t>Puerto en uso</a:t>
             </a:r>
-            <a:endParaRPr lang="en-US" sz="1300" dirty="0"/>
+            <a:endParaRPr lang="en-US" sz="1600" dirty="0"/>
           </a:p>
         </p:txBody>
       </p:sp>
@@ -8038,7 +8029,7 @@
               <a:buNone/>
             </a:pPr>
             <a:r>
-              <a:rPr lang="en-US" sz="1200" dirty="0">
+              <a:rPr lang="en-US" sz="1600" dirty="0">
                 <a:solidFill>
                   <a:srgbClr val="383A42"/>
                 </a:solidFill>
@@ -8048,7 +8039,7 @@
               </a:rPr>
               <a:t>Si el 4200 esta ocupado, se pasa --port 4300 al comando. El equipo BiblioUTEQ usa 4200 para el frontend y 8080 para la API.</a:t>
             </a:r>
-            <a:endParaRPr lang="en-US" sz="1200" dirty="0"/>
+            <a:endParaRPr lang="en-US" sz="1600" dirty="0"/>
           </a:p>
         </p:txBody>
       </p:sp>
@@ -8356,7 +8347,7 @@
               <a:buChar char="■"/>
             </a:pPr>
             <a:r>
-              <a:rPr lang="en-US" sz="1500" dirty="0">
+              <a:rPr lang="en-US" sz="2000" dirty="0">
                 <a:solidFill>
                   <a:srgbClr val="383A42"/>
                 </a:solidFill>
@@ -8366,7 +8357,7 @@
               </a:rPr>
               <a:t>File &gt; Open &gt; seleccionar la carpeta frontend/ recien creada por ng new.</a:t>
             </a:r>
-            <a:endParaRPr lang="en-US" sz="1500" dirty="0"/>
+            <a:endParaRPr lang="en-US" sz="2000" dirty="0"/>
           </a:p>
           <a:p>
             <a:pPr marL="342900" indent="-342900">
@@ -8377,7 +8368,7 @@
               <a:buChar char="■"/>
             </a:pPr>
             <a:r>
-              <a:rPr lang="en-US" sz="1500" dirty="0">
+              <a:rPr lang="en-US" sz="2000" dirty="0">
                 <a:solidFill>
                   <a:srgbClr val="383A42"/>
                 </a:solidFill>
@@ -8387,7 +8378,7 @@
               </a:rPr>
               <a:t>Confirmar la opcion Trust Project cuando IntelliJ lo solicite.</a:t>
             </a:r>
-            <a:endParaRPr lang="en-US" sz="1500" dirty="0"/>
+            <a:endParaRPr lang="en-US" sz="2000" dirty="0"/>
           </a:p>
           <a:p>
             <a:pPr marL="342900" indent="-342900">
@@ -8398,7 +8389,7 @@
               <a:buChar char="■"/>
             </a:pPr>
             <a:r>
-              <a:rPr lang="en-US" sz="1500" dirty="0">
+              <a:rPr lang="en-US" sz="2000" dirty="0">
                 <a:solidFill>
                   <a:srgbClr val="383A42"/>
                 </a:solidFill>
@@ -8408,7 +8399,7 @@
               </a:rPr>
               <a:t>IntelliJ detecta automaticamente el proyecto Angular gracias al angular.json en la raiz.</a:t>
             </a:r>
-            <a:endParaRPr lang="en-US" sz="1500" dirty="0"/>
+            <a:endParaRPr lang="en-US" sz="2000" dirty="0"/>
           </a:p>
           <a:p>
             <a:pPr marL="342900" indent="-342900">
@@ -8419,7 +8410,7 @@
               <a:buChar char="■"/>
             </a:pPr>
             <a:r>
-              <a:rPr lang="en-US" sz="1500" dirty="0">
+              <a:rPr lang="en-US" sz="2000" dirty="0">
                 <a:solidFill>
                   <a:srgbClr val="383A42"/>
                 </a:solidFill>
@@ -8429,7 +8420,7 @@
               </a:rPr>
               <a:t>En View &gt; Tool Windows &gt; Angular se abre el panel con la lista de componentes, servicios y modulos del proyecto, util para navegar.</a:t>
             </a:r>
-            <a:endParaRPr lang="en-US" sz="1500" dirty="0"/>
+            <a:endParaRPr lang="en-US" sz="2000" dirty="0"/>
           </a:p>
           <a:p>
             <a:pPr marL="342900" indent="-342900">
@@ -8440,7 +8431,7 @@
               <a:buChar char="■"/>
             </a:pPr>
             <a:r>
-              <a:rPr lang="en-US" sz="1500" dirty="0">
+              <a:rPr lang="en-US" sz="2000" dirty="0">
                 <a:solidFill>
                   <a:srgbClr val="383A42"/>
                 </a:solidFill>
@@ -8450,7 +8441,7 @@
               </a:rPr>
               <a:t>Crear una configuracion de Run &gt; Edit Configurations &gt; + &gt; npm, con script 'start' del package.json, para arrancar ng serve con un solo boton verde.</a:t>
             </a:r>
-            <a:endParaRPr lang="en-US" sz="1500" dirty="0"/>
+            <a:endParaRPr lang="en-US" sz="2000" dirty="0"/>
           </a:p>
           <a:p>
             <a:pPr marL="342900" indent="-342900">
@@ -8461,7 +8452,7 @@
               <a:buChar char="■"/>
             </a:pPr>
             <a:r>
-              <a:rPr lang="en-US" sz="1500" dirty="0">
+              <a:rPr lang="en-US" sz="2000" dirty="0">
                 <a:solidFill>
                   <a:srgbClr val="383A42"/>
                 </a:solidFill>
@@ -8471,7 +8462,7 @@
               </a:rPr>
               <a:t>Habilitar el ESLint automatico en Settings &gt; Languages and Frameworks &gt; TypeScript &gt; TSLint/ESLint para que resalte errores en tiempo real.</a:t>
             </a:r>
-            <a:endParaRPr lang="en-US" sz="1500" dirty="0"/>
+            <a:endParaRPr lang="en-US" sz="2000" dirty="0"/>
           </a:p>
         </p:txBody>
       </p:sp>
@@ -8775,7 +8766,7 @@
               <a:buNone/>
             </a:pPr>
             <a:r>
-              <a:rPr lang="en-US" sz="1500" dirty="0">
+              <a:rPr lang="en-US" dirty="0">
                 <a:solidFill>
                   <a:srgbClr val="383A42"/>
                 </a:solidFill>
@@ -8785,7 +8776,7 @@
               </a:rPr>
               <a:t>Un componente en Angular es una clase TypeScript decorada con @Component que asocia una plantilla HTML, unos estilos CSS y una logica. Es la unidad reutilizable de la interfaz: un boton, una tabla, una pagina completa.</a:t>
             </a:r>
-            <a:endParaRPr lang="en-US" sz="1500" dirty="0"/>
+            <a:endParaRPr lang="en-US" dirty="0"/>
           </a:p>
         </p:txBody>
       </p:sp>
@@ -8797,7 +8788,7 @@
         </p:nvSpPr>
         <p:spPr>
           <a:xfrm>
-            <a:off x="548640" y="2331720"/>
+            <a:off x="548640" y="1973367"/>
             <a:ext cx="11091672" cy="3520440"/>
           </a:xfrm>
           <a:prstGeom prst="roundRect">
@@ -8819,7 +8810,7 @@
           <a:bodyPr/>
           <a:lstStyle/>
           <a:p>
-            <a:endParaRPr lang="es-US"/>
+            <a:endParaRPr lang="es-US" sz="2400"/>
           </a:p>
         </p:txBody>
       </p:sp>
@@ -8831,7 +8822,7 @@
         </p:nvSpPr>
         <p:spPr>
           <a:xfrm>
-            <a:off x="548640" y="2331720"/>
+            <a:off x="548640" y="1973367"/>
             <a:ext cx="1737360" cy="274320"/>
           </a:xfrm>
           <a:prstGeom prst="rect">
@@ -8851,7 +8842,7 @@
           <a:bodyPr/>
           <a:lstStyle/>
           <a:p>
-            <a:endParaRPr lang="es-US"/>
+            <a:endParaRPr lang="es-US" sz="2400"/>
           </a:p>
         </p:txBody>
       </p:sp>
@@ -8863,7 +8854,7 @@
         </p:nvSpPr>
         <p:spPr>
           <a:xfrm>
-            <a:off x="594360" y="2350008"/>
+            <a:off x="594360" y="1991655"/>
             <a:ext cx="1691640" cy="237744"/>
           </a:xfrm>
           <a:prstGeom prst="rect">
@@ -8880,7 +8871,7 @@
               <a:buNone/>
             </a:pPr>
             <a:r>
-              <a:rPr lang="en-US" sz="1000" b="1" dirty="0">
+              <a:rPr lang="en-US" sz="1100" b="1" dirty="0">
                 <a:solidFill>
                   <a:srgbClr val="FFFFFF"/>
                 </a:solidFill>
@@ -8890,7 +8881,7 @@
               </a:rPr>
               <a:t>typescript</a:t>
             </a:r>
-            <a:endParaRPr lang="en-US" sz="1000" dirty="0"/>
+            <a:endParaRPr lang="en-US" sz="1100" dirty="0"/>
           </a:p>
         </p:txBody>
       </p:sp>
@@ -8902,7 +8893,7 @@
         </p:nvSpPr>
         <p:spPr>
           <a:xfrm>
-            <a:off x="640080" y="2679192"/>
+            <a:off x="640080" y="2320839"/>
             <a:ext cx="10908792" cy="3081528"/>
           </a:xfrm>
           <a:prstGeom prst="rect">
@@ -8919,7 +8910,7 @@
               <a:buNone/>
             </a:pPr>
             <a:r>
-              <a:rPr lang="en-US" sz="1200" i="1" dirty="0">
+              <a:rPr lang="en-US" sz="1400" i="1" dirty="0">
                 <a:solidFill>
                   <a:srgbClr val="717171"/>
                 </a:solidFill>
@@ -8931,7 +8922,7 @@
 </a:t>
             </a:r>
             <a:r>
-              <a:rPr lang="en-US" sz="1200" b="1" dirty="0">
+              <a:rPr lang="en-US" sz="1400" b="1" dirty="0">
                 <a:solidFill>
                   <a:srgbClr val="0057AE"/>
                 </a:solidFill>
@@ -8942,7 +8933,7 @@
               <a:t>import</a:t>
             </a:r>
             <a:r>
-              <a:rPr lang="en-US" sz="1200" dirty="0">
+              <a:rPr lang="en-US" sz="1400" dirty="0">
                 <a:solidFill>
                   <a:srgbClr val="383A42"/>
                 </a:solidFill>
@@ -8953,7 +8944,7 @@
               <a:t> { Component } </a:t>
             </a:r>
             <a:r>
-              <a:rPr lang="en-US" sz="1200" b="1" dirty="0">
+              <a:rPr lang="en-US" sz="1400" b="1" dirty="0">
                 <a:solidFill>
                   <a:srgbClr val="0057AE"/>
                 </a:solidFill>
@@ -8964,7 +8955,7 @@
               <a:t>from</a:t>
             </a:r>
             <a:r>
-              <a:rPr lang="en-US" sz="1200" dirty="0">
+              <a:rPr lang="en-US" sz="1400" dirty="0">
                 <a:solidFill>
                   <a:srgbClr val="383A42"/>
                 </a:solidFill>
@@ -8975,7 +8966,7 @@
               <a:t> </a:t>
             </a:r>
             <a:r>
-              <a:rPr lang="en-US" sz="1200" dirty="0">
+              <a:rPr lang="en-US" sz="1400" dirty="0">
                 <a:solidFill>
                   <a:srgbClr val="C41A16"/>
                 </a:solidFill>
@@ -8986,7 +8977,7 @@
               <a:t>'@angular/core'</a:t>
             </a:r>
             <a:r>
-              <a:rPr lang="en-US" sz="1200" dirty="0">
+              <a:rPr lang="en-US" sz="1400" dirty="0">
                 <a:solidFill>
                   <a:srgbClr val="383A42"/>
                 </a:solidFill>
@@ -8996,14 +8987,14 @@
               </a:rPr>
               <a:t>;</a:t>
             </a:r>
-            <a:endParaRPr lang="en-US" sz="1200" dirty="0"/>
-          </a:p>
-          <a:p>
-            <a:pPr marL="0" indent="0">
-              <a:buNone/>
-            </a:pPr>
-            <a:r>
-              <a:rPr lang="en-US" sz="1200" dirty="0">
+            <a:endParaRPr lang="en-US" sz="1400" dirty="0"/>
+          </a:p>
+          <a:p>
+            <a:pPr marL="0" indent="0">
+              <a:buNone/>
+            </a:pPr>
+            <a:r>
+              <a:rPr lang="en-US" sz="1400" dirty="0">
                 <a:solidFill>
                   <a:srgbClr val="383A42"/>
                 </a:solidFill>
@@ -9013,14 +9004,14 @@
               </a:rPr>
               <a:t>@Component({</a:t>
             </a:r>
-            <a:endParaRPr lang="en-US" sz="1200" dirty="0"/>
-          </a:p>
-          <a:p>
-            <a:pPr marL="0" indent="0">
-              <a:buNone/>
-            </a:pPr>
-            <a:r>
-              <a:rPr lang="en-US" sz="1200" dirty="0">
+            <a:endParaRPr lang="en-US" sz="1400" dirty="0"/>
+          </a:p>
+          <a:p>
+            <a:pPr marL="0" indent="0">
+              <a:buNone/>
+            </a:pPr>
+            <a:r>
+              <a:rPr lang="en-US" sz="1400" dirty="0">
                 <a:solidFill>
                   <a:srgbClr val="383A42"/>
                 </a:solidFill>
@@ -9031,7 +9022,7 @@
               <a:t>  selector: </a:t>
             </a:r>
             <a:r>
-              <a:rPr lang="en-US" sz="1200" dirty="0">
+              <a:rPr lang="en-US" sz="1400" dirty="0">
                 <a:solidFill>
                   <a:srgbClr val="C41A16"/>
                 </a:solidFill>
@@ -9042,7 +9033,7 @@
               <a:t>'app-</a:t>
             </a:r>
             <a:r>
-              <a:rPr lang="en-US" sz="1200" dirty="0" err="1">
+              <a:rPr lang="en-US" sz="1400" dirty="0" err="1">
                 <a:solidFill>
                   <a:srgbClr val="C41A16"/>
                 </a:solidFill>
@@ -9053,7 +9044,7 @@
               <a:t>libro</a:t>
             </a:r>
             <a:r>
-              <a:rPr lang="en-US" sz="1200" dirty="0">
+              <a:rPr lang="en-US" sz="1400" dirty="0">
                 <a:solidFill>
                   <a:srgbClr val="C41A16"/>
                 </a:solidFill>
@@ -9064,7 +9055,7 @@
               <a:t>-list'</a:t>
             </a:r>
             <a:r>
-              <a:rPr lang="en-US" sz="1200" dirty="0">
+              <a:rPr lang="en-US" sz="1400" dirty="0">
                 <a:solidFill>
                   <a:srgbClr val="383A42"/>
                 </a:solidFill>
@@ -9074,14 +9065,14 @@
               </a:rPr>
               <a:t>,</a:t>
             </a:r>
-            <a:endParaRPr lang="en-US" sz="1200" dirty="0"/>
-          </a:p>
-          <a:p>
-            <a:pPr marL="0" indent="0">
-              <a:buNone/>
-            </a:pPr>
-            <a:r>
-              <a:rPr lang="en-US" sz="1200" dirty="0">
+            <a:endParaRPr lang="en-US" sz="1400" dirty="0"/>
+          </a:p>
+          <a:p>
+            <a:pPr marL="0" indent="0">
+              <a:buNone/>
+            </a:pPr>
+            <a:r>
+              <a:rPr lang="en-US" sz="1400" dirty="0">
                 <a:solidFill>
                   <a:srgbClr val="383A42"/>
                 </a:solidFill>
@@ -9092,7 +9083,7 @@
               <a:t>  standalone: </a:t>
             </a:r>
             <a:r>
-              <a:rPr lang="en-US" sz="1200" b="1" dirty="0">
+              <a:rPr lang="en-US" sz="1400" b="1" dirty="0">
                 <a:solidFill>
                   <a:srgbClr val="0057AE"/>
                 </a:solidFill>
@@ -9103,7 +9094,7 @@
               <a:t>true</a:t>
             </a:r>
             <a:r>
-              <a:rPr lang="en-US" sz="1200" dirty="0">
+              <a:rPr lang="en-US" sz="1400" dirty="0">
                 <a:solidFill>
                   <a:srgbClr val="383A42"/>
                 </a:solidFill>
@@ -9113,14 +9104,14 @@
               </a:rPr>
               <a:t>,</a:t>
             </a:r>
-            <a:endParaRPr lang="en-US" sz="1200" dirty="0"/>
-          </a:p>
-          <a:p>
-            <a:pPr marL="0" indent="0">
-              <a:buNone/>
-            </a:pPr>
-            <a:r>
-              <a:rPr lang="en-US" sz="1200" dirty="0">
+            <a:endParaRPr lang="en-US" sz="1400" dirty="0"/>
+          </a:p>
+          <a:p>
+            <a:pPr marL="0" indent="0">
+              <a:buNone/>
+            </a:pPr>
+            <a:r>
+              <a:rPr lang="en-US" sz="1400" dirty="0">
                 <a:solidFill>
                   <a:srgbClr val="383A42"/>
                 </a:solidFill>
@@ -9131,7 +9122,7 @@
               <a:t>  template: </a:t>
             </a:r>
             <a:r>
-              <a:rPr lang="en-US" sz="1200" dirty="0">
+              <a:rPr lang="en-US" sz="1400" dirty="0">
                 <a:solidFill>
                   <a:srgbClr val="C41A16"/>
                 </a:solidFill>
@@ -9141,14 +9132,14 @@
               </a:rPr>
               <a:t>`</a:t>
             </a:r>
-            <a:endParaRPr lang="en-US" sz="1200" dirty="0"/>
-          </a:p>
-          <a:p>
-            <a:pPr marL="0" indent="0">
-              <a:buNone/>
-            </a:pPr>
-            <a:r>
-              <a:rPr lang="en-US" sz="1200" dirty="0">
+            <a:endParaRPr lang="en-US" sz="1400" dirty="0"/>
+          </a:p>
+          <a:p>
+            <a:pPr marL="0" indent="0">
+              <a:buNone/>
+            </a:pPr>
+            <a:r>
+              <a:rPr lang="en-US" sz="1400" dirty="0">
                 <a:solidFill>
                   <a:srgbClr val="383A42"/>
                 </a:solidFill>
@@ -9158,14 +9149,14 @@
               </a:rPr>
               <a:t>    &lt;h2&gt;Catalogo de libros&lt;/h2&gt;</a:t>
             </a:r>
-            <a:endParaRPr lang="en-US" sz="1200" dirty="0"/>
-          </a:p>
-          <a:p>
-            <a:pPr marL="0" indent="0">
-              <a:buNone/>
-            </a:pPr>
-            <a:r>
-              <a:rPr lang="en-US" sz="1200" dirty="0">
+            <a:endParaRPr lang="en-US" sz="1400" dirty="0"/>
+          </a:p>
+          <a:p>
+            <a:pPr marL="0" indent="0">
+              <a:buNone/>
+            </a:pPr>
+            <a:r>
+              <a:rPr lang="en-US" sz="1400" dirty="0">
                 <a:solidFill>
                   <a:srgbClr val="383A42"/>
                 </a:solidFill>
@@ -9175,14 +9166,14 @@
               </a:rPr>
               <a:t>    &lt;p&gt;Total en catalogo: {{ total }}&lt;/p&gt;</a:t>
             </a:r>
-            <a:endParaRPr lang="en-US" sz="1200" dirty="0"/>
-          </a:p>
-          <a:p>
-            <a:pPr marL="0" indent="0">
-              <a:buNone/>
-            </a:pPr>
-            <a:r>
-              <a:rPr lang="en-US" sz="1200" dirty="0">
+            <a:endParaRPr lang="en-US" sz="1400" dirty="0"/>
+          </a:p>
+          <a:p>
+            <a:pPr marL="0" indent="0">
+              <a:buNone/>
+            </a:pPr>
+            <a:r>
+              <a:rPr lang="en-US" sz="1400" dirty="0">
                 <a:solidFill>
                   <a:srgbClr val="383A42"/>
                 </a:solidFill>
@@ -9193,7 +9184,7 @@
               <a:t>  </a:t>
             </a:r>
             <a:r>
-              <a:rPr lang="en-US" sz="1200" dirty="0">
+              <a:rPr lang="en-US" sz="1400" dirty="0">
                 <a:solidFill>
                   <a:srgbClr val="C41A16"/>
                 </a:solidFill>
@@ -9203,8 +9194,170 @@
               </a:rPr>
               <a:t>`,</a:t>
             </a:r>
-            <a:r>
-              <a:rPr lang="en-US" sz="1200" dirty="0">
+            <a:endParaRPr lang="en-US" sz="1400" dirty="0"/>
+          </a:p>
+          <a:p>
+            <a:pPr marL="0" indent="0">
+              <a:buNone/>
+            </a:pPr>
+            <a:r>
+              <a:rPr lang="en-US" sz="1400" dirty="0">
+                <a:solidFill>
+                  <a:srgbClr val="383A42"/>
+                </a:solidFill>
+                <a:latin typeface="Courier New" pitchFamily="34" charset="0"/>
+                <a:ea typeface="Courier New" pitchFamily="34" charset="-122"/>
+                <a:cs typeface="Courier New" pitchFamily="34" charset="-120"/>
+              </a:rPr>
+              <a:t>  styles: [ </a:t>
+            </a:r>
+            <a:r>
+              <a:rPr lang="en-US" sz="1400" dirty="0">
+                <a:solidFill>
+                  <a:srgbClr val="C41A16"/>
+                </a:solidFill>
+                <a:latin typeface="Courier New" pitchFamily="34" charset="0"/>
+                <a:ea typeface="Courier New" pitchFamily="34" charset="-122"/>
+                <a:cs typeface="Courier New" pitchFamily="34" charset="-120"/>
+              </a:rPr>
+              <a:t>'h2 { color: #006633; }'</a:t>
+            </a:r>
+            <a:r>
+              <a:rPr lang="en-US" sz="1400" dirty="0">
+                <a:solidFill>
+                  <a:srgbClr val="383A42"/>
+                </a:solidFill>
+                <a:latin typeface="Courier New" pitchFamily="34" charset="0"/>
+                <a:ea typeface="Courier New" pitchFamily="34" charset="-122"/>
+                <a:cs typeface="Courier New" pitchFamily="34" charset="-120"/>
+              </a:rPr>
+              <a:t> ]</a:t>
+            </a:r>
+            <a:endParaRPr lang="en-US" sz="1400" dirty="0"/>
+          </a:p>
+          <a:p>
+            <a:pPr marL="0" indent="0">
+              <a:buNone/>
+            </a:pPr>
+            <a:r>
+              <a:rPr lang="en-US" sz="1400" dirty="0">
+                <a:solidFill>
+                  <a:srgbClr val="383A42"/>
+                </a:solidFill>
+                <a:latin typeface="Courier New" pitchFamily="34" charset="0"/>
+                <a:ea typeface="Courier New" pitchFamily="34" charset="-122"/>
+                <a:cs typeface="Courier New" pitchFamily="34" charset="-120"/>
+              </a:rPr>
+              <a:t>})</a:t>
+            </a:r>
+            <a:endParaRPr lang="en-US" sz="1400" dirty="0"/>
+          </a:p>
+          <a:p>
+            <a:pPr marL="0" indent="0">
+              <a:buNone/>
+            </a:pPr>
+            <a:r>
+              <a:rPr lang="en-US" sz="1400" b="1" dirty="0">
+                <a:solidFill>
+                  <a:srgbClr val="0057AE"/>
+                </a:solidFill>
+                <a:latin typeface="Courier New" pitchFamily="34" charset="0"/>
+                <a:ea typeface="Courier New" pitchFamily="34" charset="-122"/>
+                <a:cs typeface="Courier New" pitchFamily="34" charset="-120"/>
+              </a:rPr>
+              <a:t>export</a:t>
+            </a:r>
+            <a:r>
+              <a:rPr lang="en-US" sz="1400" dirty="0">
+                <a:solidFill>
+                  <a:srgbClr val="383A42"/>
+                </a:solidFill>
+                <a:latin typeface="Courier New" pitchFamily="34" charset="0"/>
+                <a:ea typeface="Courier New" pitchFamily="34" charset="-122"/>
+                <a:cs typeface="Courier New" pitchFamily="34" charset="-120"/>
+              </a:rPr>
+              <a:t> </a:t>
+            </a:r>
+            <a:r>
+              <a:rPr lang="en-US" sz="1400" b="1" dirty="0">
+                <a:solidFill>
+                  <a:srgbClr val="0057AE"/>
+                </a:solidFill>
+                <a:latin typeface="Courier New" pitchFamily="34" charset="0"/>
+                <a:ea typeface="Courier New" pitchFamily="34" charset="-122"/>
+                <a:cs typeface="Courier New" pitchFamily="34" charset="-120"/>
+              </a:rPr>
+              <a:t>class</a:t>
+            </a:r>
+            <a:r>
+              <a:rPr lang="en-US" sz="1400" dirty="0">
+                <a:solidFill>
+                  <a:srgbClr val="383A42"/>
+                </a:solidFill>
+                <a:latin typeface="Courier New" pitchFamily="34" charset="0"/>
+                <a:ea typeface="Courier New" pitchFamily="34" charset="-122"/>
+                <a:cs typeface="Courier New" pitchFamily="34" charset="-120"/>
+              </a:rPr>
+              <a:t> </a:t>
+            </a:r>
+            <a:r>
+              <a:rPr lang="en-US" sz="1400" dirty="0" err="1">
+                <a:solidFill>
+                  <a:srgbClr val="383A42"/>
+                </a:solidFill>
+                <a:latin typeface="Courier New" pitchFamily="34" charset="0"/>
+                <a:ea typeface="Courier New" pitchFamily="34" charset="-122"/>
+                <a:cs typeface="Courier New" pitchFamily="34" charset="-120"/>
+              </a:rPr>
+              <a:t>LibroListComponent</a:t>
+            </a:r>
+            <a:r>
+              <a:rPr lang="en-US" sz="1400" dirty="0">
+                <a:solidFill>
+                  <a:srgbClr val="383A42"/>
+                </a:solidFill>
+                <a:latin typeface="Courier New" pitchFamily="34" charset="0"/>
+                <a:ea typeface="Courier New" pitchFamily="34" charset="-122"/>
+                <a:cs typeface="Courier New" pitchFamily="34" charset="-120"/>
+              </a:rPr>
+              <a:t> {</a:t>
+            </a:r>
+            <a:endParaRPr lang="en-US" sz="1400" dirty="0"/>
+          </a:p>
+          <a:p>
+            <a:pPr marL="0" indent="0">
+              <a:buNone/>
+            </a:pPr>
+            <a:r>
+              <a:rPr lang="en-US" sz="1400" dirty="0">
+                <a:solidFill>
+                  <a:srgbClr val="383A42"/>
+                </a:solidFill>
+                <a:latin typeface="Courier New" pitchFamily="34" charset="0"/>
+                <a:ea typeface="Courier New" pitchFamily="34" charset="-122"/>
+                <a:cs typeface="Courier New" pitchFamily="34" charset="-120"/>
+              </a:rPr>
+              <a:t>  total = 42;</a:t>
+            </a:r>
+            <a:endParaRPr lang="en-US" sz="1400" dirty="0"/>
+          </a:p>
+          <a:p>
+            <a:pPr marL="0" indent="0">
+              <a:buNone/>
+            </a:pPr>
+            <a:r>
+              <a:rPr lang="en-US" sz="1400" dirty="0">
+                <a:solidFill>
+                  <a:srgbClr val="383A42"/>
+                </a:solidFill>
+                <a:latin typeface="Courier New" pitchFamily="34" charset="0"/>
+                <a:ea typeface="Courier New" pitchFamily="34" charset="-122"/>
+                <a:cs typeface="Courier New" pitchFamily="34" charset="-120"/>
+              </a:rPr>
+              <a:t>}</a:t>
+            </a:r>
+            <a:r>
+              <a:rPr lang="en-US" sz="1400" dirty="0">
                 <a:solidFill>
                   <a:srgbClr val="000000"/>
                 </a:solidFill>
@@ -9212,183 +9365,7 @@
               <a:t>
 </a:t>
             </a:r>
-            <a:endParaRPr lang="en-US" sz="1200" dirty="0"/>
-          </a:p>
-          <a:p>
-            <a:pPr marL="0" indent="0">
-              <a:buNone/>
-            </a:pPr>
-            <a:r>
-              <a:rPr lang="en-US" sz="1200" dirty="0">
-                <a:solidFill>
-                  <a:srgbClr val="383A42"/>
-                </a:solidFill>
-                <a:latin typeface="Courier New" pitchFamily="34" charset="0"/>
-                <a:ea typeface="Courier New" pitchFamily="34" charset="-122"/>
-                <a:cs typeface="Courier New" pitchFamily="34" charset="-120"/>
-              </a:rPr>
-              <a:t>  styles: [ </a:t>
-            </a:r>
-            <a:r>
-              <a:rPr lang="en-US" sz="1200" dirty="0">
-                <a:solidFill>
-                  <a:srgbClr val="C41A16"/>
-                </a:solidFill>
-                <a:latin typeface="Courier New" pitchFamily="34" charset="0"/>
-                <a:ea typeface="Courier New" pitchFamily="34" charset="-122"/>
-                <a:cs typeface="Courier New" pitchFamily="34" charset="-120"/>
-              </a:rPr>
-              <a:t>'h2 { color: #006633; }'</a:t>
-            </a:r>
-            <a:r>
-              <a:rPr lang="en-US" sz="1200" dirty="0">
-                <a:solidFill>
-                  <a:srgbClr val="383A42"/>
-                </a:solidFill>
-                <a:latin typeface="Courier New" pitchFamily="34" charset="0"/>
-                <a:ea typeface="Courier New" pitchFamily="34" charset="-122"/>
-                <a:cs typeface="Courier New" pitchFamily="34" charset="-120"/>
-              </a:rPr>
-              <a:t> ]</a:t>
-            </a:r>
-            <a:endParaRPr lang="en-US" sz="1200" dirty="0"/>
-          </a:p>
-          <a:p>
-            <a:pPr marL="0" indent="0">
-              <a:buNone/>
-            </a:pPr>
-            <a:r>
-              <a:rPr lang="en-US" sz="1200" dirty="0">
-                <a:solidFill>
-                  <a:srgbClr val="383A42"/>
-                </a:solidFill>
-                <a:latin typeface="Courier New" pitchFamily="34" charset="0"/>
-                <a:ea typeface="Courier New" pitchFamily="34" charset="-122"/>
-                <a:cs typeface="Courier New" pitchFamily="34" charset="-120"/>
-              </a:rPr>
-              <a:t>})</a:t>
-            </a:r>
-          </a:p>
-          <a:p>
-            <a:pPr marL="0" indent="0">
-              <a:buNone/>
-            </a:pPr>
-            <a:endParaRPr lang="en-US" sz="1200" dirty="0"/>
-          </a:p>
-          <a:p>
-            <a:pPr marL="0" indent="0">
-              <a:buNone/>
-            </a:pPr>
-            <a:r>
-              <a:rPr lang="en-US" sz="1200" b="1" dirty="0">
-                <a:solidFill>
-                  <a:srgbClr val="0057AE"/>
-                </a:solidFill>
-                <a:latin typeface="Courier New" pitchFamily="34" charset="0"/>
-                <a:ea typeface="Courier New" pitchFamily="34" charset="-122"/>
-                <a:cs typeface="Courier New" pitchFamily="34" charset="-120"/>
-              </a:rPr>
-              <a:t>export</a:t>
-            </a:r>
-            <a:r>
-              <a:rPr lang="en-US" sz="1200" dirty="0">
-                <a:solidFill>
-                  <a:srgbClr val="383A42"/>
-                </a:solidFill>
-                <a:latin typeface="Courier New" pitchFamily="34" charset="0"/>
-                <a:ea typeface="Courier New" pitchFamily="34" charset="-122"/>
-                <a:cs typeface="Courier New" pitchFamily="34" charset="-120"/>
-              </a:rPr>
-              <a:t> </a:t>
-            </a:r>
-            <a:r>
-              <a:rPr lang="en-US" sz="1200" b="1" dirty="0">
-                <a:solidFill>
-                  <a:srgbClr val="0057AE"/>
-                </a:solidFill>
-                <a:latin typeface="Courier New" pitchFamily="34" charset="0"/>
-                <a:ea typeface="Courier New" pitchFamily="34" charset="-122"/>
-                <a:cs typeface="Courier New" pitchFamily="34" charset="-120"/>
-              </a:rPr>
-              <a:t>class</a:t>
-            </a:r>
-            <a:r>
-              <a:rPr lang="en-US" sz="1200" dirty="0">
-                <a:solidFill>
-                  <a:srgbClr val="383A42"/>
-                </a:solidFill>
-                <a:latin typeface="Courier New" pitchFamily="34" charset="0"/>
-                <a:ea typeface="Courier New" pitchFamily="34" charset="-122"/>
-                <a:cs typeface="Courier New" pitchFamily="34" charset="-120"/>
-              </a:rPr>
-              <a:t> </a:t>
-            </a:r>
-            <a:r>
-              <a:rPr lang="en-US" sz="1200" dirty="0" err="1">
-                <a:solidFill>
-                  <a:srgbClr val="383A42"/>
-                </a:solidFill>
-                <a:latin typeface="Courier New" pitchFamily="34" charset="0"/>
-                <a:ea typeface="Courier New" pitchFamily="34" charset="-122"/>
-                <a:cs typeface="Courier New" pitchFamily="34" charset="-120"/>
-              </a:rPr>
-              <a:t>LibroListComponent</a:t>
-            </a:r>
-            <a:r>
-              <a:rPr lang="en-US" sz="1200" dirty="0">
-                <a:solidFill>
-                  <a:srgbClr val="383A42"/>
-                </a:solidFill>
-                <a:latin typeface="Courier New" pitchFamily="34" charset="0"/>
-                <a:ea typeface="Courier New" pitchFamily="34" charset="-122"/>
-                <a:cs typeface="Courier New" pitchFamily="34" charset="-120"/>
-              </a:rPr>
-              <a:t> {</a:t>
-            </a:r>
-            <a:endParaRPr lang="en-US" sz="1200" dirty="0"/>
-          </a:p>
-          <a:p>
-            <a:pPr marL="0" indent="0">
-              <a:buNone/>
-            </a:pPr>
-            <a:r>
-              <a:rPr lang="en-US" sz="1200" dirty="0">
-                <a:solidFill>
-                  <a:srgbClr val="383A42"/>
-                </a:solidFill>
-                <a:latin typeface="Courier New" pitchFamily="34" charset="0"/>
-                <a:ea typeface="Courier New" pitchFamily="34" charset="-122"/>
-                <a:cs typeface="Courier New" pitchFamily="34" charset="-120"/>
-              </a:rPr>
-              <a:t>  total = 42;</a:t>
-            </a:r>
-            <a:endParaRPr lang="en-US" sz="1200" dirty="0"/>
-          </a:p>
-          <a:p>
-            <a:pPr marL="0" indent="0">
-              <a:buNone/>
-            </a:pPr>
-            <a:r>
-              <a:rPr lang="en-US" sz="1200" dirty="0">
-                <a:solidFill>
-                  <a:srgbClr val="383A42"/>
-                </a:solidFill>
-                <a:latin typeface="Courier New" pitchFamily="34" charset="0"/>
-                <a:ea typeface="Courier New" pitchFamily="34" charset="-122"/>
-                <a:cs typeface="Courier New" pitchFamily="34" charset="-120"/>
-              </a:rPr>
-              <a:t>}</a:t>
-            </a:r>
-            <a:r>
-              <a:rPr lang="en-US" sz="1200" dirty="0">
-                <a:solidFill>
-                  <a:srgbClr val="000000"/>
-                </a:solidFill>
-              </a:rPr>
-              <a:t>
-</a:t>
-            </a:r>
-            <a:endParaRPr lang="en-US" sz="1200" dirty="0"/>
+            <a:endParaRPr lang="en-US" sz="1400" dirty="0"/>
           </a:p>
         </p:txBody>
       </p:sp>
@@ -9400,7 +9377,7 @@
         </p:nvSpPr>
         <p:spPr>
           <a:xfrm>
-            <a:off x="457200" y="5907024"/>
+            <a:off x="457200" y="5635170"/>
             <a:ext cx="11091672" cy="548640"/>
           </a:xfrm>
           <a:prstGeom prst="rect">
@@ -9417,7 +9394,7 @@
               <a:buNone/>
             </a:pPr>
             <a:r>
-              <a:rPr lang="en-US" sz="1300" i="1" dirty="0">
+              <a:rPr lang="en-US" sz="1600" i="1" dirty="0">
                 <a:solidFill>
                   <a:srgbClr val="383A42"/>
                 </a:solidFill>
@@ -9427,7 +9404,7 @@
               </a:rPr>
               <a:t>El decorador @Component enlaza la clase con su HTML, su CSS y un selector &lt;app-libro-list&gt;. Cualquier plantilla que incluya esa etiqueta renderizara este componente. La bandera standalone:true, que es el default en Angular 22, permite usar el componente sin declararlo en un NgModule.</a:t>
             </a:r>
-            <a:endParaRPr lang="en-US" sz="1300" dirty="0"/>
+            <a:endParaRPr lang="en-US" sz="1600" dirty="0"/>
           </a:p>
         </p:txBody>
       </p:sp>
@@ -9731,7 +9708,7 @@
               <a:buNone/>
             </a:pPr>
             <a:r>
-              <a:rPr lang="en-US" sz="1500" dirty="0">
+              <a:rPr lang="en-US" dirty="0">
                 <a:solidFill>
                   <a:srgbClr val="383A42"/>
                 </a:solidFill>
@@ -9741,7 +9718,7 @@
               </a:rPr>
               <a:t>En vez de escribir el componente a mano, la CLI lo genera con el andamiaje correcto: archivo .ts, .html, .css, .spec.ts, y lo registra automaticamente en las importaciones si es hijo de la app.</a:t>
             </a:r>
-            <a:endParaRPr lang="en-US" sz="1500" dirty="0"/>
+            <a:endParaRPr lang="en-US" dirty="0"/>
           </a:p>
         </p:txBody>
       </p:sp>
@@ -9775,7 +9752,7 @@
           <a:bodyPr/>
           <a:lstStyle/>
           <a:p>
-            <a:endParaRPr lang="es-US"/>
+            <a:endParaRPr lang="es-US" sz="2400"/>
           </a:p>
         </p:txBody>
       </p:sp>
@@ -9807,7 +9784,7 @@
           <a:bodyPr/>
           <a:lstStyle/>
           <a:p>
-            <a:endParaRPr lang="es-US"/>
+            <a:endParaRPr lang="es-US" sz="2400"/>
           </a:p>
         </p:txBody>
       </p:sp>
@@ -9836,7 +9813,7 @@
               <a:buNone/>
             </a:pPr>
             <a:r>
-              <a:rPr lang="en-US" sz="1000" b="1" dirty="0">
+              <a:rPr lang="en-US" sz="1200" b="1" dirty="0">
                 <a:solidFill>
                   <a:srgbClr val="FFFFFF"/>
                 </a:solidFill>
@@ -9846,7 +9823,7 @@
               </a:rPr>
               <a:t>terminal</a:t>
             </a:r>
-            <a:endParaRPr lang="en-US" sz="1000" dirty="0"/>
+            <a:endParaRPr lang="en-US" sz="1200" dirty="0"/>
           </a:p>
         </p:txBody>
       </p:sp>
@@ -9875,7 +9852,7 @@
               <a:buNone/>
             </a:pPr>
             <a:r>
-              <a:rPr lang="en-US" sz="1300" i="1" dirty="0">
+              <a:rPr lang="en-US" i="1" dirty="0">
                 <a:solidFill>
                   <a:srgbClr val="717171"/>
                 </a:solidFill>
@@ -9887,7 +9864,7 @@
 </a:t>
             </a:r>
             <a:r>
-              <a:rPr lang="en-US" sz="1300" b="1" dirty="0">
+              <a:rPr lang="en-US" b="1" dirty="0">
                 <a:solidFill>
                   <a:srgbClr val="0057AE"/>
                 </a:solidFill>
@@ -9898,7 +9875,7 @@
               <a:t>ng</a:t>
             </a:r>
             <a:r>
-              <a:rPr lang="en-US" sz="1300" dirty="0">
+              <a:rPr lang="en-US" dirty="0">
                 <a:solidFill>
                   <a:srgbClr val="383A42"/>
                 </a:solidFill>
@@ -9909,7 +9886,7 @@
               <a:t> </a:t>
             </a:r>
             <a:r>
-              <a:rPr lang="en-US" sz="1300" b="1" dirty="0">
+              <a:rPr lang="en-US" b="1" dirty="0">
                 <a:solidFill>
                   <a:srgbClr val="0057AE"/>
                 </a:solidFill>
@@ -9920,7 +9897,7 @@
               <a:t>generate</a:t>
             </a:r>
             <a:r>
-              <a:rPr lang="en-US" sz="1300" dirty="0">
+              <a:rPr lang="en-US" dirty="0">
                 <a:solidFill>
                   <a:srgbClr val="383A42"/>
                 </a:solidFill>
@@ -9931,7 +9908,7 @@
               <a:t> component </a:t>
             </a:r>
             <a:r>
-              <a:rPr lang="en-US" sz="1300" dirty="0" err="1">
+              <a:rPr lang="en-US" dirty="0" err="1">
                 <a:solidFill>
                   <a:srgbClr val="383A42"/>
                 </a:solidFill>
@@ -9942,7 +9919,7 @@
               <a:t>libro</a:t>
             </a:r>
             <a:r>
-              <a:rPr lang="en-US" sz="1300" dirty="0">
+              <a:rPr lang="en-US" dirty="0">
                 <a:solidFill>
                   <a:srgbClr val="383A42"/>
                 </a:solidFill>
@@ -9952,8 +9929,154 @@
               </a:rPr>
               <a:t>-list</a:t>
             </a:r>
-            <a:r>
-              <a:rPr lang="en-US" sz="1300" dirty="0">
+            <a:endParaRPr lang="en-US" dirty="0"/>
+          </a:p>
+          <a:p>
+            <a:pPr marL="0" indent="0">
+              <a:buNone/>
+            </a:pPr>
+            <a:r>
+              <a:rPr lang="en-US" i="1" dirty="0">
+                <a:solidFill>
+                  <a:srgbClr val="717171"/>
+                </a:solidFill>
+                <a:latin typeface="Courier New" pitchFamily="34" charset="0"/>
+                <a:ea typeface="Courier New" pitchFamily="34" charset="-122"/>
+                <a:cs typeface="Courier New" pitchFamily="34" charset="-120"/>
+              </a:rPr>
+              <a:t># Forma abreviada (equivalente)
+</a:t>
+            </a:r>
+            <a:r>
+              <a:rPr lang="en-US" b="1" dirty="0">
+                <a:solidFill>
+                  <a:srgbClr val="0057AE"/>
+                </a:solidFill>
+                <a:latin typeface="Courier New" pitchFamily="34" charset="0"/>
+                <a:ea typeface="Courier New" pitchFamily="34" charset="-122"/>
+                <a:cs typeface="Courier New" pitchFamily="34" charset="-120"/>
+              </a:rPr>
+              <a:t>ng</a:t>
+            </a:r>
+            <a:r>
+              <a:rPr lang="en-US" dirty="0">
+                <a:solidFill>
+                  <a:srgbClr val="383A42"/>
+                </a:solidFill>
+                <a:latin typeface="Courier New" pitchFamily="34" charset="0"/>
+                <a:ea typeface="Courier New" pitchFamily="34" charset="-122"/>
+                <a:cs typeface="Courier New" pitchFamily="34" charset="-120"/>
+              </a:rPr>
+              <a:t> </a:t>
+            </a:r>
+            <a:r>
+              <a:rPr lang="en-US" b="1" dirty="0">
+                <a:solidFill>
+                  <a:srgbClr val="0057AE"/>
+                </a:solidFill>
+                <a:latin typeface="Courier New" pitchFamily="34" charset="0"/>
+                <a:ea typeface="Courier New" pitchFamily="34" charset="-122"/>
+                <a:cs typeface="Courier New" pitchFamily="34" charset="-120"/>
+              </a:rPr>
+              <a:t>g</a:t>
+            </a:r>
+            <a:r>
+              <a:rPr lang="en-US" dirty="0">
+                <a:solidFill>
+                  <a:srgbClr val="383A42"/>
+                </a:solidFill>
+                <a:latin typeface="Courier New" pitchFamily="34" charset="0"/>
+                <a:ea typeface="Courier New" pitchFamily="34" charset="-122"/>
+                <a:cs typeface="Courier New" pitchFamily="34" charset="-120"/>
+              </a:rPr>
+              <a:t> c </a:t>
+            </a:r>
+            <a:r>
+              <a:rPr lang="en-US" dirty="0" err="1">
+                <a:solidFill>
+                  <a:srgbClr val="383A42"/>
+                </a:solidFill>
+                <a:latin typeface="Courier New" pitchFamily="34" charset="0"/>
+                <a:ea typeface="Courier New" pitchFamily="34" charset="-122"/>
+                <a:cs typeface="Courier New" pitchFamily="34" charset="-120"/>
+              </a:rPr>
+              <a:t>libro</a:t>
+            </a:r>
+            <a:r>
+              <a:rPr lang="en-US" dirty="0">
+                <a:solidFill>
+                  <a:srgbClr val="383A42"/>
+                </a:solidFill>
+                <a:latin typeface="Courier New" pitchFamily="34" charset="0"/>
+                <a:ea typeface="Courier New" pitchFamily="34" charset="-122"/>
+                <a:cs typeface="Courier New" pitchFamily="34" charset="-120"/>
+              </a:rPr>
+              <a:t>-list</a:t>
+            </a:r>
+            <a:endParaRPr lang="en-US" dirty="0"/>
+          </a:p>
+          <a:p>
+            <a:pPr marL="0" indent="0">
+              <a:buNone/>
+            </a:pPr>
+            <a:r>
+              <a:rPr lang="en-US" i="1" dirty="0">
+                <a:solidFill>
+                  <a:srgbClr val="717171"/>
+                </a:solidFill>
+                <a:latin typeface="Courier New" pitchFamily="34" charset="0"/>
+                <a:ea typeface="Courier New" pitchFamily="34" charset="-122"/>
+                <a:cs typeface="Courier New" pitchFamily="34" charset="-120"/>
+              </a:rPr>
+              <a:t># Con opciones
+</a:t>
+            </a:r>
+            <a:r>
+              <a:rPr lang="en-US" b="1" dirty="0">
+                <a:solidFill>
+                  <a:srgbClr val="0057AE"/>
+                </a:solidFill>
+                <a:latin typeface="Courier New" pitchFamily="34" charset="0"/>
+                <a:ea typeface="Courier New" pitchFamily="34" charset="-122"/>
+                <a:cs typeface="Courier New" pitchFamily="34" charset="-120"/>
+              </a:rPr>
+              <a:t>ng</a:t>
+            </a:r>
+            <a:r>
+              <a:rPr lang="en-US" dirty="0">
+                <a:solidFill>
+                  <a:srgbClr val="383A42"/>
+                </a:solidFill>
+                <a:latin typeface="Courier New" pitchFamily="34" charset="0"/>
+                <a:ea typeface="Courier New" pitchFamily="34" charset="-122"/>
+                <a:cs typeface="Courier New" pitchFamily="34" charset="-120"/>
+              </a:rPr>
+              <a:t> </a:t>
+            </a:r>
+            <a:r>
+              <a:rPr lang="en-US" b="1" dirty="0">
+                <a:solidFill>
+                  <a:srgbClr val="0057AE"/>
+                </a:solidFill>
+                <a:latin typeface="Courier New" pitchFamily="34" charset="0"/>
+                <a:ea typeface="Courier New" pitchFamily="34" charset="-122"/>
+                <a:cs typeface="Courier New" pitchFamily="34" charset="-120"/>
+              </a:rPr>
+              <a:t>g</a:t>
+            </a:r>
+            <a:r>
+              <a:rPr lang="en-US" dirty="0">
+                <a:solidFill>
+                  <a:srgbClr val="383A42"/>
+                </a:solidFill>
+                <a:latin typeface="Courier New" pitchFamily="34" charset="0"/>
+                <a:ea typeface="Courier New" pitchFamily="34" charset="-122"/>
+                <a:cs typeface="Courier New" pitchFamily="34" charset="-120"/>
+              </a:rPr>
+              <a:t> c libros/libro-list --skip-tests --inline-style</a:t>
+            </a:r>
+            <a:r>
+              <a:rPr lang="en-US" dirty="0">
                 <a:solidFill>
                   <a:srgbClr val="000000"/>
                 </a:solidFill>
@@ -9961,171 +10084,7 @@
               <a:t>
 </a:t>
             </a:r>
-            <a:endParaRPr lang="en-US" sz="1300" dirty="0"/>
-          </a:p>
-          <a:p>
-            <a:pPr marL="0" indent="0">
-              <a:buNone/>
-            </a:pPr>
-            <a:r>
-              <a:rPr lang="en-US" sz="1300" i="1" dirty="0">
-                <a:solidFill>
-                  <a:srgbClr val="717171"/>
-                </a:solidFill>
-                <a:latin typeface="Courier New" pitchFamily="34" charset="0"/>
-                <a:ea typeface="Courier New" pitchFamily="34" charset="-122"/>
-                <a:cs typeface="Courier New" pitchFamily="34" charset="-120"/>
-              </a:rPr>
-              <a:t># Forma abreviada (equivalente)
-</a:t>
-            </a:r>
-            <a:r>
-              <a:rPr lang="en-US" sz="1300" b="1" dirty="0">
-                <a:solidFill>
-                  <a:srgbClr val="0057AE"/>
-                </a:solidFill>
-                <a:latin typeface="Courier New" pitchFamily="34" charset="0"/>
-                <a:ea typeface="Courier New" pitchFamily="34" charset="-122"/>
-                <a:cs typeface="Courier New" pitchFamily="34" charset="-120"/>
-              </a:rPr>
-              <a:t>ng</a:t>
-            </a:r>
-            <a:r>
-              <a:rPr lang="en-US" sz="1300" dirty="0">
-                <a:solidFill>
-                  <a:srgbClr val="383A42"/>
-                </a:solidFill>
-                <a:latin typeface="Courier New" pitchFamily="34" charset="0"/>
-                <a:ea typeface="Courier New" pitchFamily="34" charset="-122"/>
-                <a:cs typeface="Courier New" pitchFamily="34" charset="-120"/>
-              </a:rPr>
-              <a:t> </a:t>
-            </a:r>
-            <a:r>
-              <a:rPr lang="en-US" sz="1300" b="1" dirty="0">
-                <a:solidFill>
-                  <a:srgbClr val="0057AE"/>
-                </a:solidFill>
-                <a:latin typeface="Courier New" pitchFamily="34" charset="0"/>
-                <a:ea typeface="Courier New" pitchFamily="34" charset="-122"/>
-                <a:cs typeface="Courier New" pitchFamily="34" charset="-120"/>
-              </a:rPr>
-              <a:t>g</a:t>
-            </a:r>
-            <a:r>
-              <a:rPr lang="en-US" sz="1300" dirty="0">
-                <a:solidFill>
-                  <a:srgbClr val="383A42"/>
-                </a:solidFill>
-                <a:latin typeface="Courier New" pitchFamily="34" charset="0"/>
-                <a:ea typeface="Courier New" pitchFamily="34" charset="-122"/>
-                <a:cs typeface="Courier New" pitchFamily="34" charset="-120"/>
-              </a:rPr>
-              <a:t> c </a:t>
-            </a:r>
-            <a:r>
-              <a:rPr lang="en-US" sz="1300" dirty="0" err="1">
-                <a:solidFill>
-                  <a:srgbClr val="383A42"/>
-                </a:solidFill>
-                <a:latin typeface="Courier New" pitchFamily="34" charset="0"/>
-                <a:ea typeface="Courier New" pitchFamily="34" charset="-122"/>
-                <a:cs typeface="Courier New" pitchFamily="34" charset="-120"/>
-              </a:rPr>
-              <a:t>libro</a:t>
-            </a:r>
-            <a:r>
-              <a:rPr lang="en-US" sz="1300" dirty="0">
-                <a:solidFill>
-                  <a:srgbClr val="383A42"/>
-                </a:solidFill>
-                <a:latin typeface="Courier New" pitchFamily="34" charset="0"/>
-                <a:ea typeface="Courier New" pitchFamily="34" charset="-122"/>
-                <a:cs typeface="Courier New" pitchFamily="34" charset="-120"/>
-              </a:rPr>
-              <a:t>-list</a:t>
-            </a:r>
-            <a:r>
-              <a:rPr lang="en-US" sz="1300" dirty="0">
-                <a:solidFill>
-                  <a:srgbClr val="000000"/>
-                </a:solidFill>
-              </a:rPr>
-              <a:t>
-</a:t>
-            </a:r>
-            <a:endParaRPr lang="en-US" sz="1300" dirty="0"/>
-          </a:p>
-          <a:p>
-            <a:pPr marL="0" indent="0">
-              <a:buNone/>
-            </a:pPr>
-            <a:r>
-              <a:rPr lang="en-US" sz="1300" i="1" dirty="0">
-                <a:solidFill>
-                  <a:srgbClr val="717171"/>
-                </a:solidFill>
-                <a:latin typeface="Courier New" pitchFamily="34" charset="0"/>
-                <a:ea typeface="Courier New" pitchFamily="34" charset="-122"/>
-                <a:cs typeface="Courier New" pitchFamily="34" charset="-120"/>
-              </a:rPr>
-              <a:t># Con opciones
-</a:t>
-            </a:r>
-            <a:r>
-              <a:rPr lang="en-US" sz="1300" b="1" dirty="0">
-                <a:solidFill>
-                  <a:srgbClr val="0057AE"/>
-                </a:solidFill>
-                <a:latin typeface="Courier New" pitchFamily="34" charset="0"/>
-                <a:ea typeface="Courier New" pitchFamily="34" charset="-122"/>
-                <a:cs typeface="Courier New" pitchFamily="34" charset="-120"/>
-              </a:rPr>
-              <a:t>ng</a:t>
-            </a:r>
-            <a:r>
-              <a:rPr lang="en-US" sz="1300" dirty="0">
-                <a:solidFill>
-                  <a:srgbClr val="383A42"/>
-                </a:solidFill>
-                <a:latin typeface="Courier New" pitchFamily="34" charset="0"/>
-                <a:ea typeface="Courier New" pitchFamily="34" charset="-122"/>
-                <a:cs typeface="Courier New" pitchFamily="34" charset="-120"/>
-              </a:rPr>
-              <a:t> </a:t>
-            </a:r>
-            <a:r>
-              <a:rPr lang="en-US" sz="1300" b="1" dirty="0">
-                <a:solidFill>
-                  <a:srgbClr val="0057AE"/>
-                </a:solidFill>
-                <a:latin typeface="Courier New" pitchFamily="34" charset="0"/>
-                <a:ea typeface="Courier New" pitchFamily="34" charset="-122"/>
-                <a:cs typeface="Courier New" pitchFamily="34" charset="-120"/>
-              </a:rPr>
-              <a:t>g</a:t>
-            </a:r>
-            <a:r>
-              <a:rPr lang="en-US" sz="1300" dirty="0">
-                <a:solidFill>
-                  <a:srgbClr val="383A42"/>
-                </a:solidFill>
-                <a:latin typeface="Courier New" pitchFamily="34" charset="0"/>
-                <a:ea typeface="Courier New" pitchFamily="34" charset="-122"/>
-                <a:cs typeface="Courier New" pitchFamily="34" charset="-120"/>
-              </a:rPr>
-              <a:t> c libros/libro-list --skip-tests --inline-style</a:t>
-            </a:r>
-            <a:r>
-              <a:rPr lang="en-US" sz="1300" dirty="0">
-                <a:solidFill>
-                  <a:srgbClr val="000000"/>
-                </a:solidFill>
-              </a:rPr>
-              <a:t>
-</a:t>
-            </a:r>
-            <a:endParaRPr lang="en-US" sz="1300" dirty="0"/>
+            <a:endParaRPr lang="en-US" dirty="0"/>
           </a:p>
         </p:txBody>
       </p:sp>
@@ -10159,7 +10118,7 @@
           <a:bodyPr/>
           <a:lstStyle/>
           <a:p>
-            <a:endParaRPr lang="es-US"/>
+            <a:endParaRPr lang="es-US" sz="2400"/>
           </a:p>
         </p:txBody>
       </p:sp>
@@ -10191,7 +10150,7 @@
           <a:bodyPr/>
           <a:lstStyle/>
           <a:p>
-            <a:endParaRPr lang="es-US"/>
+            <a:endParaRPr lang="es-US" sz="2400"/>
           </a:p>
         </p:txBody>
       </p:sp>
@@ -10220,7 +10179,7 @@
               <a:buNone/>
             </a:pPr>
             <a:r>
-              <a:rPr lang="en-US" sz="1300" b="1" dirty="0">
+              <a:rPr lang="en-US" sz="1600" b="1" dirty="0">
                 <a:solidFill>
                   <a:srgbClr val="FFFFFF"/>
                 </a:solidFill>
@@ -10230,7 +10189,7 @@
               </a:rPr>
               <a:t>Archivos creados</a:t>
             </a:r>
-            <a:endParaRPr lang="en-US" sz="1300" dirty="0"/>
+            <a:endParaRPr lang="en-US" sz="1600" dirty="0"/>
           </a:p>
         </p:txBody>
       </p:sp>
@@ -10262,7 +10221,7 @@
               <a:buNone/>
             </a:pPr>
             <a:r>
-              <a:rPr lang="en-US" sz="1200" dirty="0">
+              <a:rPr lang="en-US" sz="1600" dirty="0">
                 <a:solidFill>
                   <a:srgbClr val="383A42"/>
                 </a:solidFill>
@@ -10272,7 +10231,7 @@
               </a:rPr>
               <a:t>libro-list.component.ts (clase con @Component), .html (template), .css (estilos scoped) y .spec.ts (esqueleto de pruebas con Jasmine).</a:t>
             </a:r>
-            <a:endParaRPr lang="en-US" sz="1200" dirty="0"/>
+            <a:endParaRPr lang="en-US" sz="1600" dirty="0"/>
           </a:p>
         </p:txBody>
       </p:sp>
@@ -10306,7 +10265,7 @@
           <a:bodyPr/>
           <a:lstStyle/>
           <a:p>
-            <a:endParaRPr lang="es-US"/>
+            <a:endParaRPr lang="es-US" sz="2400"/>
           </a:p>
         </p:txBody>
       </p:sp>
@@ -10338,7 +10297,7 @@
           <a:bodyPr/>
           <a:lstStyle/>
           <a:p>
-            <a:endParaRPr lang="es-US"/>
+            <a:endParaRPr lang="es-US" sz="2400"/>
           </a:p>
         </p:txBody>
       </p:sp>
@@ -10367,7 +10326,7 @@
               <a:buNone/>
             </a:pPr>
             <a:r>
-              <a:rPr lang="en-US" sz="1300" b="1" dirty="0">
+              <a:rPr lang="en-US" sz="1600" b="1" dirty="0">
                 <a:solidFill>
                   <a:srgbClr val="FFFFFF"/>
                 </a:solidFill>
@@ -10377,7 +10336,7 @@
               </a:rPr>
               <a:t>Buena practica</a:t>
             </a:r>
-            <a:endParaRPr lang="en-US" sz="1300" dirty="0"/>
+            <a:endParaRPr lang="en-US" sz="1600" dirty="0"/>
           </a:p>
         </p:txBody>
       </p:sp>
@@ -10409,7 +10368,7 @@
               <a:buNone/>
             </a:pPr>
             <a:r>
-              <a:rPr lang="en-US" sz="1200" dirty="0">
+              <a:rPr lang="en-US" sz="1600" dirty="0">
                 <a:solidFill>
                   <a:srgbClr val="383A42"/>
                 </a:solidFill>
@@ -10419,7 +10378,7 @@
               </a:rPr>
               <a:t>Agrupar componentes por caracteristica en subcarpetas: libros/, prestamos/, usuarios/. La opcion libros/libro-list crea el componente ya en esa carpeta.</a:t>
             </a:r>
-            <a:endParaRPr lang="en-US" sz="1200" dirty="0"/>
+            <a:endParaRPr lang="en-US" sz="1600" dirty="0"/>
           </a:p>
         </p:txBody>
       </p:sp>
@@ -10723,7 +10682,7 @@
               <a:buNone/>
             </a:pPr>
             <a:r>
-              <a:rPr lang="en-US" sz="1500" dirty="0">
+              <a:rPr lang="en-US" dirty="0">
                 <a:solidFill>
                   <a:srgbClr val="383A42"/>
                 </a:solidFill>
@@ -10733,7 +10692,7 @@
               </a:rPr>
               <a:t>Data binding es el mecanismo por el que Angular sincroniza el modelo (la clase TypeScript) con la vista (el HTML). Hay cuatro variantes esenciales.</a:t>
             </a:r>
-            <a:endParaRPr lang="en-US" sz="1500" dirty="0"/>
+            <a:endParaRPr lang="en-US" dirty="0"/>
           </a:p>
         </p:txBody>
       </p:sp>
@@ -10767,7 +10726,7 @@
           <a:bodyPr/>
           <a:lstStyle/>
           <a:p>
-            <a:endParaRPr lang="es-US"/>
+            <a:endParaRPr lang="es-US" sz="2400"/>
           </a:p>
         </p:txBody>
       </p:sp>
@@ -10799,7 +10758,7 @@
           <a:bodyPr/>
           <a:lstStyle/>
           <a:p>
-            <a:endParaRPr lang="es-US"/>
+            <a:endParaRPr lang="es-US" sz="2400"/>
           </a:p>
         </p:txBody>
       </p:sp>
@@ -10828,7 +10787,7 @@
               <a:buNone/>
             </a:pPr>
             <a:r>
-              <a:rPr lang="en-US" sz="1300" b="1" dirty="0">
+              <a:rPr lang="en-US" sz="1600" b="1" dirty="0">
                 <a:solidFill>
                   <a:srgbClr val="FFFFFF"/>
                 </a:solidFill>
@@ -10838,7 +10797,7 @@
               </a:rPr>
               <a:t>Interpolacion</a:t>
             </a:r>
-            <a:endParaRPr lang="en-US" sz="1300" dirty="0"/>
+            <a:endParaRPr lang="en-US" sz="1600" dirty="0"/>
           </a:p>
         </p:txBody>
       </p:sp>
@@ -10867,7 +10826,7 @@
               <a:buNone/>
             </a:pPr>
             <a:r>
-              <a:rPr lang="en-US" sz="1400" b="1" dirty="0">
+              <a:rPr lang="en-US" b="1" dirty="0">
                 <a:solidFill>
                   <a:srgbClr val="0057AE"/>
                 </a:solidFill>
@@ -10877,7 +10836,7 @@
               </a:rPr>
               <a:t>{{ libro.titulo }}</a:t>
             </a:r>
-            <a:endParaRPr lang="en-US" sz="1400" dirty="0"/>
+            <a:endParaRPr lang="en-US" dirty="0"/>
           </a:p>
         </p:txBody>
       </p:sp>
@@ -10906,7 +10865,7 @@
               <a:buNone/>
             </a:pPr>
             <a:r>
-              <a:rPr lang="en-US" sz="1200" dirty="0">
+              <a:rPr lang="en-US" sz="1600" dirty="0">
                 <a:solidFill>
                   <a:srgbClr val="383A42"/>
                 </a:solidFill>
@@ -10916,7 +10875,7 @@
               </a:rPr>
               <a:t>Muestra el valor de una expresion en el DOM.</a:t>
             </a:r>
-            <a:endParaRPr lang="en-US" sz="1200" dirty="0"/>
+            <a:endParaRPr lang="en-US" sz="1600" dirty="0"/>
           </a:p>
         </p:txBody>
       </p:sp>
@@ -10950,7 +10909,7 @@
           <a:bodyPr/>
           <a:lstStyle/>
           <a:p>
-            <a:endParaRPr lang="es-US"/>
+            <a:endParaRPr lang="es-US" sz="2400"/>
           </a:p>
         </p:txBody>
       </p:sp>
@@ -10982,7 +10941,7 @@
           <a:bodyPr/>
           <a:lstStyle/>
           <a:p>
-            <a:endParaRPr lang="es-US"/>
+            <a:endParaRPr lang="es-US" sz="2400"/>
           </a:p>
         </p:txBody>
       </p:sp>
@@ -11011,7 +10970,7 @@
               <a:buNone/>
             </a:pPr>
             <a:r>
-              <a:rPr lang="en-US" sz="1300" b="1" dirty="0">
+              <a:rPr lang="en-US" sz="1600" b="1" dirty="0">
                 <a:solidFill>
                   <a:srgbClr val="FFFFFF"/>
                 </a:solidFill>
@@ -11021,7 +10980,7 @@
               </a:rPr>
               <a:t>Property binding</a:t>
             </a:r>
-            <a:endParaRPr lang="en-US" sz="1300" dirty="0"/>
+            <a:endParaRPr lang="en-US" sz="1600" dirty="0"/>
           </a:p>
         </p:txBody>
       </p:sp>
@@ -11050,7 +11009,7 @@
               <a:buNone/>
             </a:pPr>
             <a:r>
-              <a:rPr lang="en-US" sz="1400" b="1" dirty="0">
+              <a:rPr lang="en-US" b="1" dirty="0">
                 <a:solidFill>
                   <a:srgbClr val="0057AE"/>
                 </a:solidFill>
@@ -11060,7 +11019,7 @@
               </a:rPr>
               <a:t>[value]="libro.titulo"</a:t>
             </a:r>
-            <a:endParaRPr lang="en-US" sz="1400" dirty="0"/>
+            <a:endParaRPr lang="en-US" dirty="0"/>
           </a:p>
         </p:txBody>
       </p:sp>
@@ -11089,7 +11048,7 @@
               <a:buNone/>
             </a:pPr>
             <a:r>
-              <a:rPr lang="en-US" sz="1200" dirty="0">
+              <a:rPr lang="en-US" sz="1600" dirty="0">
                 <a:solidFill>
                   <a:srgbClr val="383A42"/>
                 </a:solidFill>
@@ -11099,7 +11058,7 @@
               </a:rPr>
               <a:t>Asigna un valor a una propiedad del elemento HTML.</a:t>
             </a:r>
-            <a:endParaRPr lang="en-US" sz="1200" dirty="0"/>
+            <a:endParaRPr lang="en-US" sz="1600" dirty="0"/>
           </a:p>
         </p:txBody>
       </p:sp>
@@ -11133,7 +11092,7 @@
           <a:bodyPr/>
           <a:lstStyle/>
           <a:p>
-            <a:endParaRPr lang="es-US"/>
+            <a:endParaRPr lang="es-US" sz="2400"/>
           </a:p>
         </p:txBody>
       </p:sp>
@@ -11165,7 +11124,7 @@
           <a:bodyPr/>
           <a:lstStyle/>
           <a:p>
-            <a:endParaRPr lang="es-US"/>
+            <a:endParaRPr lang="es-US" sz="2400"/>
           </a:p>
         </p:txBody>
       </p:sp>
@@ -11194,7 +11153,7 @@
               <a:buNone/>
             </a:pPr>
             <a:r>
-              <a:rPr lang="en-US" sz="1300" b="1" dirty="0">
+              <a:rPr lang="en-US" sz="1600" b="1" dirty="0">
                 <a:solidFill>
                   <a:srgbClr val="FFFFFF"/>
                 </a:solidFill>
@@ -11204,7 +11163,7 @@
               </a:rPr>
               <a:t>Event binding</a:t>
             </a:r>
-            <a:endParaRPr lang="en-US" sz="1300" dirty="0"/>
+            <a:endParaRPr lang="en-US" sz="1600" dirty="0"/>
           </a:p>
         </p:txBody>
       </p:sp>
@@ -11233,7 +11192,7 @@
               <a:buNone/>
             </a:pPr>
             <a:r>
-              <a:rPr lang="en-US" sz="1400" b="1" dirty="0">
+              <a:rPr lang="en-US" b="1" dirty="0">
                 <a:solidFill>
                   <a:srgbClr val="0057AE"/>
                 </a:solidFill>
@@ -11243,7 +11202,7 @@
               </a:rPr>
               <a:t>(click)="onGuardar()"</a:t>
             </a:r>
-            <a:endParaRPr lang="en-US" sz="1400" dirty="0"/>
+            <a:endParaRPr lang="en-US" dirty="0"/>
           </a:p>
         </p:txBody>
       </p:sp>
@@ -11272,7 +11231,7 @@
               <a:buNone/>
             </a:pPr>
             <a:r>
-              <a:rPr lang="en-US" sz="1200" dirty="0">
+              <a:rPr lang="en-US" sz="1600" dirty="0">
                 <a:solidFill>
                   <a:srgbClr val="383A42"/>
                 </a:solidFill>
@@ -11282,7 +11241,7 @@
               </a:rPr>
               <a:t>Enlaza un evento del DOM a un metodo de la clase.</a:t>
             </a:r>
-            <a:endParaRPr lang="en-US" sz="1200" dirty="0"/>
+            <a:endParaRPr lang="en-US" sz="1600" dirty="0"/>
           </a:p>
         </p:txBody>
       </p:sp>
@@ -11316,7 +11275,7 @@
           <a:bodyPr/>
           <a:lstStyle/>
           <a:p>
-            <a:endParaRPr lang="es-US"/>
+            <a:endParaRPr lang="es-US" sz="2400"/>
           </a:p>
         </p:txBody>
       </p:sp>
@@ -11348,7 +11307,7 @@
           <a:bodyPr/>
           <a:lstStyle/>
           <a:p>
-            <a:endParaRPr lang="es-US"/>
+            <a:endParaRPr lang="es-US" sz="2400"/>
           </a:p>
         </p:txBody>
       </p:sp>
@@ -11377,7 +11336,7 @@
               <a:buNone/>
             </a:pPr>
             <a:r>
-              <a:rPr lang="en-US" sz="1300" b="1" dirty="0">
+              <a:rPr lang="en-US" sz="1600" b="1" dirty="0">
                 <a:solidFill>
                   <a:srgbClr val="FFFFFF"/>
                 </a:solidFill>
@@ -11387,7 +11346,7 @@
               </a:rPr>
               <a:t>Two-way binding</a:t>
             </a:r>
-            <a:endParaRPr lang="en-US" sz="1300" dirty="0"/>
+            <a:endParaRPr lang="en-US" sz="1600" dirty="0"/>
           </a:p>
         </p:txBody>
       </p:sp>
@@ -11416,7 +11375,7 @@
               <a:buNone/>
             </a:pPr>
             <a:r>
-              <a:rPr lang="en-US" sz="1400" b="1" dirty="0">
+              <a:rPr lang="en-US" b="1" dirty="0">
                 <a:solidFill>
                   <a:srgbClr val="0057AE"/>
                 </a:solidFill>
@@ -11426,7 +11385,7 @@
               </a:rPr>
               <a:t>[(ngModel)]="libro.titulo"</a:t>
             </a:r>
-            <a:endParaRPr lang="en-US" sz="1400" dirty="0"/>
+            <a:endParaRPr lang="en-US" dirty="0"/>
           </a:p>
         </p:txBody>
       </p:sp>
@@ -11455,7 +11414,7 @@
               <a:buNone/>
             </a:pPr>
             <a:r>
-              <a:rPr lang="en-US" sz="1200" dirty="0">
+              <a:rPr lang="en-US" sz="1600" dirty="0">
                 <a:solidFill>
                   <a:srgbClr val="383A42"/>
                 </a:solidFill>
@@ -11465,7 +11424,7 @@
               </a:rPr>
               <a:t>Sincronia bidireccional; requiere FormsModule.</a:t>
             </a:r>
-            <a:endParaRPr lang="en-US" sz="1200" dirty="0"/>
+            <a:endParaRPr lang="en-US" sz="1600" dirty="0"/>
           </a:p>
         </p:txBody>
       </p:sp>
@@ -28228,7 +28187,7 @@
               <a:buNone/>
             </a:pPr>
             <a:r>
-              <a:rPr lang="en-US" sz="1500" dirty="0">
+              <a:rPr lang="en-US" dirty="0">
                 <a:solidFill>
                   <a:srgbClr val="383A42"/>
                 </a:solidFill>
@@ -28238,7 +28197,7 @@
               </a:rPr>
               <a:t>El Router de Angular asocia URLs a componentes. La configuracion vive en app.routes.ts y el HTML principal declara donde se renderiza el componente activo con &lt;router-outlet&gt;.</a:t>
             </a:r>
-            <a:endParaRPr lang="en-US" sz="1500" dirty="0"/>
+            <a:endParaRPr lang="en-US" dirty="0"/>
           </a:p>
         </p:txBody>
       </p:sp>
@@ -29646,7 +29605,7 @@
               <a:buNone/>
             </a:pPr>
             <a:r>
-              <a:rPr lang="en-US" sz="1500" dirty="0">
+              <a:rPr lang="en-US" dirty="0">
                 <a:solidFill>
                   <a:srgbClr val="383A42"/>
                 </a:solidFill>
@@ -29656,7 +29615,7 @@
               </a:rPr>
               <a:t>Con las piezas anteriores ya integradas, el flujo del catalogo publico de BiblioUTEQ queda funcional. El aprendiz puede navegar a /libros, ver la lista y hacer clic para ver el detalle.</a:t>
             </a:r>
-            <a:endParaRPr lang="en-US" sz="1500" dirty="0"/>
+            <a:endParaRPr lang="en-US" dirty="0"/>
           </a:p>
         </p:txBody>
       </p:sp>
@@ -29690,7 +29649,7 @@
           <a:bodyPr/>
           <a:lstStyle/>
           <a:p>
-            <a:endParaRPr lang="es-US"/>
+            <a:endParaRPr lang="es-US" sz="2400"/>
           </a:p>
         </p:txBody>
       </p:sp>
@@ -29719,7 +29678,7 @@
               <a:buNone/>
             </a:pPr>
             <a:r>
-              <a:rPr lang="en-US" sz="1300" b="1" dirty="0">
+              <a:rPr lang="en-US" sz="1600" b="1" dirty="0">
                 <a:solidFill>
                   <a:srgbClr val="FFFFFF"/>
                 </a:solidFill>
@@ -29729,14 +29688,14 @@
               </a:rPr>
               <a:t>Navegador</a:t>
             </a:r>
-            <a:endParaRPr lang="en-US" sz="1300" dirty="0"/>
+            <a:endParaRPr lang="en-US" sz="1600" dirty="0"/>
           </a:p>
           <a:p>
             <a:pPr marL="0" indent="0" algn="ctr">
               <a:buNone/>
             </a:pPr>
             <a:r>
-              <a:rPr lang="en-US" sz="1300" b="1" dirty="0">
+              <a:rPr lang="en-US" sz="1600" b="1" dirty="0">
                 <a:solidFill>
                   <a:srgbClr val="FFFFFF"/>
                 </a:solidFill>
@@ -29746,7 +29705,7 @@
               </a:rPr>
               <a:t>(Angular 4200)</a:t>
             </a:r>
-            <a:endParaRPr lang="en-US" sz="1300" dirty="0"/>
+            <a:endParaRPr lang="en-US" sz="1600" dirty="0"/>
           </a:p>
         </p:txBody>
       </p:sp>
@@ -29777,7 +29736,7 @@
           <a:bodyPr/>
           <a:lstStyle/>
           <a:p>
-            <a:endParaRPr lang="es-US"/>
+            <a:endParaRPr lang="es-US" sz="2400"/>
           </a:p>
         </p:txBody>
       </p:sp>
@@ -29811,7 +29770,7 @@
           <a:bodyPr/>
           <a:lstStyle/>
           <a:p>
-            <a:endParaRPr lang="es-US"/>
+            <a:endParaRPr lang="es-US" sz="2400"/>
           </a:p>
         </p:txBody>
       </p:sp>
@@ -29840,7 +29799,7 @@
               <a:buNone/>
             </a:pPr>
             <a:r>
-              <a:rPr lang="en-US" sz="1300" b="1" dirty="0">
+              <a:rPr lang="en-US" sz="1600" b="1" dirty="0">
                 <a:solidFill>
                   <a:srgbClr val="FFFFFF"/>
                 </a:solidFill>
@@ -29850,14 +29809,14 @@
               </a:rPr>
               <a:t>HttpClient</a:t>
             </a:r>
-            <a:endParaRPr lang="en-US" sz="1300" dirty="0"/>
+            <a:endParaRPr lang="en-US" sz="1600" dirty="0"/>
           </a:p>
           <a:p>
             <a:pPr marL="0" indent="0" algn="ctr">
               <a:buNone/>
             </a:pPr>
             <a:r>
-              <a:rPr lang="en-US" sz="1300" b="1" dirty="0">
+              <a:rPr lang="en-US" sz="1600" b="1" dirty="0">
                 <a:solidFill>
                   <a:srgbClr val="FFFFFF"/>
                 </a:solidFill>
@@ -29867,7 +29826,7 @@
               </a:rPr>
               <a:t>con Interceptor</a:t>
             </a:r>
-            <a:endParaRPr lang="en-US" sz="1300" dirty="0"/>
+            <a:endParaRPr lang="en-US" sz="1600" dirty="0"/>
           </a:p>
         </p:txBody>
       </p:sp>
@@ -29898,7 +29857,7 @@
           <a:bodyPr/>
           <a:lstStyle/>
           <a:p>
-            <a:endParaRPr lang="es-US"/>
+            <a:endParaRPr lang="es-US" sz="2400"/>
           </a:p>
         </p:txBody>
       </p:sp>
@@ -29932,7 +29891,7 @@
           <a:bodyPr/>
           <a:lstStyle/>
           <a:p>
-            <a:endParaRPr lang="es-US"/>
+            <a:endParaRPr lang="es-US" sz="2400"/>
           </a:p>
         </p:txBody>
       </p:sp>
@@ -29961,7 +29920,7 @@
               <a:buNone/>
             </a:pPr>
             <a:r>
-              <a:rPr lang="en-US" sz="1300" b="1" dirty="0">
+              <a:rPr lang="en-US" sz="1600" b="1" dirty="0">
                 <a:solidFill>
                   <a:srgbClr val="FFFFFF"/>
                 </a:solidFill>
@@ -29971,14 +29930,14 @@
               </a:rPr>
               <a:t>CORS</a:t>
             </a:r>
-            <a:endParaRPr lang="en-US" sz="1300" dirty="0"/>
+            <a:endParaRPr lang="en-US" sz="1600" dirty="0"/>
           </a:p>
           <a:p>
             <a:pPr marL="0" indent="0" algn="ctr">
               <a:buNone/>
             </a:pPr>
             <a:r>
-              <a:rPr lang="en-US" sz="1300" b="1" dirty="0">
+              <a:rPr lang="en-US" sz="1600" b="1" dirty="0">
                 <a:solidFill>
                   <a:srgbClr val="FFFFFF"/>
                 </a:solidFill>
@@ -29988,7 +29947,7 @@
               </a:rPr>
               <a:t>preflight</a:t>
             </a:r>
-            <a:endParaRPr lang="en-US" sz="1300" dirty="0"/>
+            <a:endParaRPr lang="en-US" sz="1600" dirty="0"/>
           </a:p>
         </p:txBody>
       </p:sp>
@@ -30019,7 +29978,7 @@
           <a:bodyPr/>
           <a:lstStyle/>
           <a:p>
-            <a:endParaRPr lang="es-US"/>
+            <a:endParaRPr lang="es-US" sz="2400"/>
           </a:p>
         </p:txBody>
       </p:sp>
@@ -30053,7 +30012,7 @@
           <a:bodyPr/>
           <a:lstStyle/>
           <a:p>
-            <a:endParaRPr lang="es-US"/>
+            <a:endParaRPr lang="es-US" sz="2400"/>
           </a:p>
         </p:txBody>
       </p:sp>
@@ -30082,7 +30041,7 @@
               <a:buNone/>
             </a:pPr>
             <a:r>
-              <a:rPr lang="en-US" sz="1300" b="1" dirty="0">
+              <a:rPr lang="en-US" sz="1600" b="1" dirty="0">
                 <a:solidFill>
                   <a:srgbClr val="FFFFFF"/>
                 </a:solidFill>
@@ -30092,14 +30051,14 @@
               </a:rPr>
               <a:t>Spring Boot</a:t>
             </a:r>
-            <a:endParaRPr lang="en-US" sz="1300" dirty="0"/>
+            <a:endParaRPr lang="en-US" sz="1600" dirty="0"/>
           </a:p>
           <a:p>
             <a:pPr marL="0" indent="0" algn="ctr">
               <a:buNone/>
             </a:pPr>
             <a:r>
-              <a:rPr lang="en-US" sz="1300" b="1" dirty="0">
+              <a:rPr lang="en-US" sz="1600" b="1" dirty="0">
                 <a:solidFill>
                   <a:srgbClr val="FFFFFF"/>
                 </a:solidFill>
@@ -30109,7 +30068,7 @@
               </a:rPr>
               <a:t>(8080 /api)</a:t>
             </a:r>
-            <a:endParaRPr lang="en-US" sz="1300" dirty="0"/>
+            <a:endParaRPr lang="en-US" sz="1600" dirty="0"/>
           </a:p>
         </p:txBody>
       </p:sp>
@@ -30204,7 +30163,7 @@
               <a:buNone/>
             </a:pPr>
             <a:r>
-              <a:rPr lang="en-US" sz="1000" b="1" dirty="0">
+              <a:rPr lang="en-US" sz="1100" b="1" dirty="0">
                 <a:solidFill>
                   <a:srgbClr val="FFFFFF"/>
                 </a:solidFill>
@@ -30214,7 +30173,7 @@
               </a:rPr>
               <a:t>arranque completo</a:t>
             </a:r>
-            <a:endParaRPr lang="en-US" sz="1000" dirty="0"/>
+            <a:endParaRPr lang="en-US" sz="1100" dirty="0"/>
           </a:p>
         </p:txBody>
       </p:sp>
@@ -30296,7 +30255,18 @@
                 <a:ea typeface="Courier New" pitchFamily="34" charset="-122"/>
                 <a:cs typeface="Courier New" pitchFamily="34" charset="-120"/>
               </a:rPr>
-              <a:t> &amp;&amp; mvn spring-boot:run</a:t>
+              <a:t> &amp;&amp; mvn </a:t>
+            </a:r>
+            <a:r>
+              <a:rPr lang="en-US" dirty="0" err="1">
+                <a:solidFill>
+                  <a:srgbClr val="383A42"/>
+                </a:solidFill>
+                <a:latin typeface="Courier New" pitchFamily="34" charset="0"/>
+                <a:ea typeface="Courier New" pitchFamily="34" charset="-122"/>
+                <a:cs typeface="Courier New" pitchFamily="34" charset="-120"/>
+              </a:rPr>
+              <a:t>spring-boot:run</a:t>
             </a:r>
             <a:r>
               <a:rPr lang="en-US" dirty="0">
@@ -30307,21 +30277,11 @@
               <a:t>
 </a:t>
             </a:r>
-            <a:endParaRPr lang="en-US" dirty="0"/>
-          </a:p>
-          <a:p>
-            <a:pPr marL="0" indent="0">
-              <a:buNone/>
-            </a:pPr>
-            <a:r>
-              <a:rPr lang="en-US" dirty="0">
-                <a:solidFill>
-                  <a:srgbClr val="000000"/>
-                </a:solidFill>
-              </a:rPr>
-              <a:t>
-</a:t>
-            </a:r>
+          </a:p>
+          <a:p>
+            <a:pPr marL="0" indent="0">
+              <a:buNone/>
+            </a:pPr>
             <a:endParaRPr lang="en-US" dirty="0"/>
           </a:p>
           <a:p>

</xml_diff>